<commit_message>
corrections du lien de anim scroll css dans la nav (yml) et introduction au projet intégrateur et cours 7.2
</commit_message>
<xml_diff>
--- a/docs/582-511-web5/assets/documents/Web5_integrateur-lancement.pptx
+++ b/docs/582-511-web5/assets/documents/Web5_integrateur-lancement.pptx
@@ -25,9 +25,10 @@
     <p:sldId id="273" r:id="rId19"/>
     <p:sldId id="274" r:id="rId20"/>
     <p:sldId id="275" r:id="rId21"/>
+    <p:sldId id="276" r:id="rId22"/>
   </p:sldIdLst>
   <p:notesMasterIdLst>
-    <p:notesMasterId r:id="rId22"/>
+    <p:notesMasterId r:id="rId23"/>
   </p:notesMasterIdLst>
   <p:sldSz cx="12192000" cy="6858000"/>
   <p:notesSz cx="6858000" cy="12192000"/>
@@ -126,7 +127,7 @@
   <p:extLst>
     <p:ext uri="{521415D9-36F7-43E2-AB2F-B90AF26B5E84}">
       <p14:sectionLst xmlns:p14="http://schemas.microsoft.com/office/powerpoint/2010/main">
-        <p14:section name="Le projet" id="{af282f5f-ea4a-2c97-bca7-68490bf4f514}">
+        <p14:section name="Le projet" id="{4b76c4ba-0e39-e532-cf33-04ca0da3877b}">
           <p14:sldIdLst>
             <p14:sldId id="256"/>
             <p14:sldId id="257"/>
@@ -134,7 +135,7 @@
             <p14:sldId id="259"/>
           </p14:sldIdLst>
         </p14:section>
-        <p14:section name="Le produit" id="{1fa5154b-d629-b6a9-291e-d1e2c439f7d2}">
+        <p14:section name="Le produit" id="{be339f70-c34b-1921-e161-df3c41fcac5f}">
           <p14:sldIdLst>
             <p14:sldId id="260"/>
             <p14:sldId id="261"/>
@@ -145,25 +146,26 @@
             <p14:sldId id="266"/>
           </p14:sldIdLst>
         </p14:section>
-        <p14:section name="Évaluation" id="{7b45596d-a0a4-6dc0-3a6a-a3a689d25df6}">
+        <p14:section name="Évaluation" id="{6f6666ed-7905-c7f7-6611-3ca2815fd807}">
           <p14:sldIdLst>
             <p14:sldId id="267"/>
             <p14:sldId id="268"/>
             <p14:sldId id="269"/>
           </p14:sldIdLst>
         </p14:section>
-        <p14:section name="Calendrier" id="{7d77f6b9-8dd0-5688-6d0e-b4de3d06ecf0}">
+        <p14:section name="Calendrier" id="{fc2b929c-8937-3101-7ce3-1dd766dd3b73}">
           <p14:sldIdLst>
             <p14:sldId id="270"/>
             <p14:sldId id="271"/>
+            <p14:sldId id="272"/>
           </p14:sldIdLst>
         </p14:section>
-        <p14:section name="À vous" id="{944e52ab-b6c5-cf70-d691-c93202d1e0cc}">
+        <p14:section name="À vous" id="{498334d9-4333-c60d-5def-a2ce69a5ff38}">
           <p14:sldIdLst>
-            <p14:sldId id="272"/>
             <p14:sldId id="273"/>
             <p14:sldId id="274"/>
             <p14:sldId id="275"/>
+            <p14:sldId id="276"/>
           </p14:sldIdLst>
         </p14:section>
       </p14:sectionLst>
@@ -1186,7 +1188,7 @@
           <a:p>
             <a:r>
               <a:rPr lang="en-US" dirty="0"/>
-              <a:t>Les mêmes règles qu'au portfolio. Usage non documenté : plagiat. Code que vous ne comprenez pas : ça se voit à la défense.</a:t>
+              <a:t>Le point le plus important sur l'IA. Ce qui est évalué, ce n'est pas seulement le résultat : c'est votre démarche, étape par étape. Nul besoin de tout faire générer sans vous questionner : un projet produit d'un coup ne montre rien de ce que vous savez faire.</a:t>
             </a:r>
             <a:endParaRPr lang="en-US" dirty="0"/>
           </a:p>
@@ -1274,7 +1276,7 @@
           <a:p>
             <a:r>
               <a:rPr lang="en-US" dirty="0"/>
-              <a:t>Tout est dans la page des consignes et le gabarit du cahier de charges. Suivez l'ordre : le contenu d'abord, les animations ensuite, la matrice ensemble.</a:t>
+              <a:t>Je vais vous demander de me montrer votre projet à chaque étape. Si je sens qu'une étape a été sautée, par exemple un chapitre complet généré sans storyboard ni compréhension, je vais vous demander de la recommencer. Et ce sera la même règle pour tout le monde. L'IA reste permise, aux mêmes conditions qu'au portfolio : documentée dans le journal, et comprise. Ça se verra à la défense.</a:t>
             </a:r>
             <a:endParaRPr lang="en-US" dirty="0"/>
           </a:p>
@@ -1362,7 +1364,7 @@
           <a:p>
             <a:r>
               <a:rPr lang="en-US" dirty="0"/>
-              <a:t>GSAP, le CSS au défilement et Vue arrivent en classe à partir du 28 octobre. Bien planifier maintenant, c'est coder plus vite ensuite.</a:t>
+              <a:t>Tout est dans la page des consignes et le gabarit du cahier de charges. Suivez l'ordre : le contenu d'abord, les animations ensuite, la matrice ensemble.</a:t>
             </a:r>
             <a:endParaRPr lang="en-US" dirty="0"/>
           </a:p>
@@ -1450,7 +1452,7 @@
           <a:p>
             <a:r>
               <a:rPr lang="en-US" dirty="0"/>
-              <a:t>C'est la remise 1, 5 % de la note, en équipe. Je fais la rétroaction le 23, et vous commencez à coder la semaine suivante.</a:t>
+              <a:t>GSAP, le CSS au défilement et Vue arrivent en classe à partir du 28 octobre. Bien planifier maintenant, c'est coder plus vite ensuite.</a:t>
             </a:r>
             <a:endParaRPr lang="en-US" dirty="0"/>
           </a:p>
@@ -1626,7 +1628,7 @@
           <a:p>
             <a:r>
               <a:rPr lang="en-US" dirty="0"/>
-              <a:t>Gr. Enric : votre jury de portfolio est jeudi prochain. Gardez-le en priorité, mais lancez au moins le thème et le dépôt aujourd'hui.</a:t>
+              <a:t>C'est la remise 1, 5 % de la note, en équipe. Je fais la rétroaction le 23, et vous commencez à coder la semaine suivante.</a:t>
             </a:r>
             <a:endParaRPr lang="en-US" dirty="0"/>
           </a:p>
@@ -1650,6 +1652,94 @@
             <a:fld id="{F7021451-1387-4CA6-816F-3879F97B5CBC}" type="slidenum">
               <a:rPr lang="en-US"/>
               <a:t>20</a:t>
+            </a:fld>
+            <a:endParaRPr lang="en-US"/>
+          </a:p>
+        </p:txBody>
+      </p:sp>
+    </p:spTree>
+    <p:extLst>
+      <p:ext uri="{BB962C8B-B14F-4D97-AF65-F5344CB8AC3E}">
+        <p14:creationId xmlns:p14="http://schemas.microsoft.com/office/powerpoint/2010/main" val="1024086991"/>
+      </p:ext>
+    </p:extLst>
+  </p:cSld>
+  <p:clrMapOvr>
+    <a:masterClrMapping/>
+  </p:clrMapOvr>
+</p:notes>
+</file>
+
+<file path=ppt/notesSlides/notesSlide21.xml><?xml version="1.0" encoding="utf-8"?>
+<p:notes xmlns:a="http://schemas.openxmlformats.org/drawingml/2006/main" xmlns:r="http://schemas.openxmlformats.org/officeDocument/2006/relationships" xmlns:p="http://schemas.openxmlformats.org/presentationml/2006/main">
+  <p:cSld>
+    <p:spTree>
+      <p:nvGrpSpPr>
+        <p:cNvPr id="1" name=""/>
+        <p:cNvGrpSpPr/>
+        <p:nvPr/>
+      </p:nvGrpSpPr>
+      <p:grpSpPr>
+        <a:xfrm>
+          <a:off x="0" y="0"/>
+          <a:ext cx="0" cy="0"/>
+          <a:chOff x="0" y="0"/>
+          <a:chExt cx="0" cy="0"/>
+        </a:xfrm>
+      </p:grpSpPr>
+      <p:sp>
+        <p:nvSpPr>
+          <p:cNvPr id="2" name="Slide Image Placeholder 1"/>
+          <p:cNvSpPr>
+            <a:spLocks noGrp="1" noRot="1" noChangeAspect="1"/>
+          </p:cNvSpPr>
+          <p:nvPr>
+            <p:ph type="sldImg"/>
+          </p:nvPr>
+        </p:nvSpPr>
+        <p:spPr/>
+      </p:sp>
+      <p:sp>
+        <p:nvSpPr>
+          <p:cNvPr id="3" name="Notes Placeholder 2"/>
+          <p:cNvSpPr>
+            <a:spLocks noGrp="1"/>
+          </p:cNvSpPr>
+          <p:nvPr>
+            <p:ph type="body" idx="1"/>
+          </p:nvPr>
+        </p:nvSpPr>
+        <p:spPr/>
+        <p:txBody>
+          <a:bodyPr/>
+          <a:lstStyle/>
+          <a:p>
+            <a:r>
+              <a:rPr lang="en-US" dirty="0"/>
+              <a:t>Gr. Enric : votre jury de portfolio est jeudi prochain. Gardez-le en priorité, mais lancez au moins le thème et le dépôt aujourd'hui.</a:t>
+            </a:r>
+            <a:endParaRPr lang="en-US" dirty="0"/>
+          </a:p>
+        </p:txBody>
+      </p:sp>
+      <p:sp>
+        <p:nvSpPr>
+          <p:cNvPr id="4" name="Slide Number Placeholder 3"/>
+          <p:cNvSpPr>
+            <a:spLocks noGrp="1"/>
+          </p:cNvSpPr>
+          <p:nvPr>
+            <p:ph type="sldNum" sz="quarter" idx="10"/>
+          </p:nvPr>
+        </p:nvSpPr>
+        <p:spPr/>
+        <p:txBody>
+          <a:bodyPr/>
+          <a:lstStyle/>
+          <a:p>
+            <a:fld id="{F7021451-1387-4CA6-816F-3879F97B5CBC}" type="slidenum">
+              <a:rPr lang="en-US"/>
+              <a:t>21</a:t>
             </a:fld>
             <a:endParaRPr lang="en-US"/>
           </a:p>
@@ -6695,8 +6785,8 @@
         </p:nvSpPr>
         <p:spPr>
           <a:xfrm>
-            <a:off x="731520" y="411480"/>
-            <a:ext cx="10698480" cy="822960"/>
+            <a:off x="731520" y="1828800"/>
+            <a:ext cx="10698480" cy="2377440"/>
           </a:xfrm>
           <a:prstGeom prst="rect">
             <a:avLst/>
@@ -6712,27 +6802,49 @@
               <a:buNone/>
             </a:pPr>
             <a:r>
-              <a:rPr lang="en-US" sz="3200" b="1" dirty="0">
+              <a:rPr lang="en-US" sz="6000" b="1" dirty="0">
                 <a:solidFill>
                   <a:schemeClr val="tx1"/>
                 </a:solidFill>
               </a:rPr>
-              <a:t>L'IA dans le projet</a:t>
-            </a:r>
-            <a:endParaRPr lang="en-US" sz="3200" dirty="0"/>
-          </a:p>
-        </p:txBody>
-      </p:sp>
-      <p:sp>
-        <p:nvSpPr>
-          <p:cNvPr id="3" name="Text 1"/>
-          <p:cNvSpPr txBox="1"/>
-          <p:nvPr/>
-        </p:nvSpPr>
-        <p:spPr>
-          <a:xfrm>
-            <a:off x="731520" y="2194560"/>
-            <a:ext cx="3291840" cy="1188720"/>
+              <a:t>C'est votre </a:t>
+            </a:r>
+            <a:pPr algn="l" indent="0" marL="0">
+              <a:buNone/>
+            </a:pPr>
+            <a:r>
+              <a:rPr lang="en-US" sz="6000" b="1" dirty="0">
+                <a:solidFill>
+                  <a:schemeClr val="accent1"/>
+                </a:solidFill>
+              </a:rPr>
+              <a:t>processus</a:t>
+            </a:r>
+            <a:pPr algn="l" indent="0" marL="0">
+              <a:buNone/>
+            </a:pPr>
+            <a:r>
+              <a:rPr lang="en-US" sz="6000" b="1" dirty="0">
+                <a:solidFill>
+                  <a:schemeClr val="tx1"/>
+                </a:solidFill>
+              </a:rPr>
+              <a:t> qui est évalué.</a:t>
+            </a:r>
+            <a:endParaRPr lang="en-US" sz="6000" dirty="0"/>
+          </a:p>
+        </p:txBody>
+      </p:sp>
+      <p:sp>
+        <p:nvSpPr>
+          <p:cNvPr id="3" name="kicker"/>
+          <p:cNvSpPr txBox="1"/>
+          <p:nvPr/>
+        </p:nvSpPr>
+        <p:spPr>
+          <a:xfrm>
+            <a:off x="731520" y="1463040"/>
+            <a:ext cx="10698480" cy="365760"/>
           </a:xfrm>
           <a:prstGeom prst="rect">
             <a:avLst/>
@@ -6748,186 +6860,14 @@
               <a:buNone/>
             </a:pPr>
             <a:r>
-              <a:rPr lang="en-US" sz="3600" b="1" dirty="0">
-                <a:solidFill>
-                  <a:schemeClr val="accent1"/>
-                </a:solidFill>
-              </a:rPr>
-              <a:t>Permise</a:t>
-            </a:r>
-            <a:endParaRPr lang="en-US" sz="3600" dirty="0"/>
-          </a:p>
-        </p:txBody>
-      </p:sp>
-      <p:sp>
-        <p:nvSpPr>
-          <p:cNvPr id="4" name="Text 2"/>
-          <p:cNvSpPr txBox="1"/>
-          <p:nvPr/>
-        </p:nvSpPr>
-        <p:spPr>
-          <a:xfrm>
-            <a:off x="731520" y="3474720"/>
-            <a:ext cx="3291840" cy="822960"/>
-          </a:xfrm>
-          <a:prstGeom prst="rect">
-            <a:avLst/>
-          </a:prstGeom>
-          <a:noFill/>
-          <a:ln/>
-        </p:spPr>
-        <p:txBody>
-          <a:bodyPr wrap="square" lIns="0" tIns="0" rIns="0" bIns="0" rtlCol="0" anchor="t"/>
-          <a:lstStyle/>
-          <a:p>
-            <a:pPr indent="0" marL="0">
-              <a:buNone/>
-            </a:pPr>
-            <a:endParaRPr lang="en-US" sz="1800" dirty="0"/>
-          </a:p>
-        </p:txBody>
-      </p:sp>
-      <p:sp>
-        <p:nvSpPr>
-          <p:cNvPr id="5" name="Text 3"/>
-          <p:cNvSpPr txBox="1"/>
-          <p:nvPr/>
-        </p:nvSpPr>
-        <p:spPr>
-          <a:xfrm>
-            <a:off x="4297680" y="2194560"/>
-            <a:ext cx="3291840" cy="1188720"/>
-          </a:xfrm>
-          <a:prstGeom prst="rect">
-            <a:avLst/>
-          </a:prstGeom>
-          <a:noFill/>
-          <a:ln/>
-        </p:spPr>
-        <p:txBody>
-          <a:bodyPr wrap="square" lIns="0" tIns="0" rIns="0" bIns="0" rtlCol="0" anchor="ctr"/>
-          <a:lstStyle/>
-          <a:p>
-            <a:pPr indent="0" marL="0">
-              <a:buNone/>
-            </a:pPr>
-            <a:r>
-              <a:rPr lang="en-US" sz="3600" b="1" dirty="0">
-                <a:solidFill>
-                  <a:schemeClr val="tx1"/>
-                </a:solidFill>
-              </a:rPr>
-              <a:t>Documentée</a:t>
-            </a:r>
-            <a:endParaRPr lang="en-US" sz="3600" dirty="0"/>
-          </a:p>
-        </p:txBody>
-      </p:sp>
-      <p:sp>
-        <p:nvSpPr>
-          <p:cNvPr id="6" name="Text 4"/>
-          <p:cNvSpPr txBox="1"/>
-          <p:nvPr/>
-        </p:nvSpPr>
-        <p:spPr>
-          <a:xfrm>
-            <a:off x="4297680" y="3474720"/>
-            <a:ext cx="3291840" cy="822960"/>
-          </a:xfrm>
-          <a:prstGeom prst="rect">
-            <a:avLst/>
-          </a:prstGeom>
-          <a:noFill/>
-          <a:ln/>
-        </p:spPr>
-        <p:txBody>
-          <a:bodyPr wrap="square" lIns="0" tIns="0" rIns="0" bIns="0" rtlCol="0" anchor="t"/>
-          <a:lstStyle/>
-          <a:p>
-            <a:pPr indent="0" marL="0">
-              <a:buNone/>
-            </a:pPr>
-            <a:r>
-              <a:rPr lang="en-US" sz="1800" dirty="0">
+              <a:rPr lang="en-US" sz="1300" spc="400" kern="0" dirty="0">
                 <a:solidFill>
                   <a:schemeClr val="tx2"/>
                 </a:solidFill>
               </a:rPr>
-              <a:t>dans votre journal</a:t>
-            </a:r>
-            <a:endParaRPr lang="en-US" sz="1800" dirty="0"/>
-          </a:p>
-        </p:txBody>
-      </p:sp>
-      <p:sp>
-        <p:nvSpPr>
-          <p:cNvPr id="7" name="Text 5"/>
-          <p:cNvSpPr txBox="1"/>
-          <p:nvPr/>
-        </p:nvSpPr>
-        <p:spPr>
-          <a:xfrm>
-            <a:off x="7863840" y="2194560"/>
-            <a:ext cx="3291840" cy="1188720"/>
-          </a:xfrm>
-          <a:prstGeom prst="rect">
-            <a:avLst/>
-          </a:prstGeom>
-          <a:noFill/>
-          <a:ln/>
-        </p:spPr>
-        <p:txBody>
-          <a:bodyPr wrap="square" lIns="0" tIns="0" rIns="0" bIns="0" rtlCol="0" anchor="ctr"/>
-          <a:lstStyle/>
-          <a:p>
-            <a:pPr indent="0" marL="0">
-              <a:buNone/>
-            </a:pPr>
-            <a:r>
-              <a:rPr lang="en-US" sz="3600" b="1" dirty="0">
-                <a:solidFill>
-                  <a:schemeClr val="tx1"/>
-                </a:solidFill>
-              </a:rPr>
-              <a:t>Comprise</a:t>
-            </a:r>
-            <a:endParaRPr lang="en-US" sz="3600" dirty="0"/>
-          </a:p>
-        </p:txBody>
-      </p:sp>
-      <p:sp>
-        <p:nvSpPr>
-          <p:cNvPr id="8" name="Text 6"/>
-          <p:cNvSpPr txBox="1"/>
-          <p:nvPr/>
-        </p:nvSpPr>
-        <p:spPr>
-          <a:xfrm>
-            <a:off x="7863840" y="3474720"/>
-            <a:ext cx="3291840" cy="822960"/>
-          </a:xfrm>
-          <a:prstGeom prst="rect">
-            <a:avLst/>
-          </a:prstGeom>
-          <a:noFill/>
-          <a:ln/>
-        </p:spPr>
-        <p:txBody>
-          <a:bodyPr wrap="square" lIns="0" tIns="0" rIns="0" bIns="0" rtlCol="0" anchor="t"/>
-          <a:lstStyle/>
-          <a:p>
-            <a:pPr indent="0" marL="0">
-              <a:buNone/>
-            </a:pPr>
-            <a:r>
-              <a:rPr lang="en-US" sz="1800" dirty="0">
-                <a:solidFill>
-                  <a:schemeClr val="tx2"/>
-                </a:solidFill>
-              </a:rPr>
-              <a:t>à la défense</a:t>
-            </a:r>
-            <a:endParaRPr lang="en-US" sz="1800" dirty="0"/>
+              <a:t>L'IA DANS LE PROJET</a:t>
+            </a:r>
+            <a:endParaRPr lang="en-US" sz="1300" dirty="0"/>
           </a:p>
         </p:txBody>
       </p:sp>
@@ -7033,7 +6973,7 @@
                   <a:schemeClr val="tx1"/>
                 </a:solidFill>
               </a:rPr>
-              <a:t>Vos deux prochaines semaines</a:t>
+              <a:t>Étape par étape</a:t>
             </a:r>
             <a:endParaRPr lang="en-US" sz="3200" dirty="0"/>
           </a:p>
@@ -7047,7 +6987,7 @@
         </p:nvSpPr>
         <p:spPr>
           <a:xfrm>
-            <a:off x="731520" y="1508760"/>
+            <a:off x="731520" y="1645920"/>
             <a:ext cx="566928" cy="566928"/>
           </a:xfrm>
           <a:prstGeom prst="ellipse">
@@ -7072,7 +7012,7 @@
         </p:nvSpPr>
         <p:spPr>
           <a:xfrm>
-            <a:off x="731520" y="1508760"/>
+            <a:off x="731520" y="1645920"/>
             <a:ext cx="566928" cy="566928"/>
           </a:xfrm>
           <a:prstGeom prst="rect">
@@ -7108,7 +7048,7 @@
         </p:nvSpPr>
         <p:spPr>
           <a:xfrm>
-            <a:off x="1508760" y="1472184"/>
+            <a:off x="1508760" y="1609344"/>
             <a:ext cx="9875520" cy="365760"/>
           </a:xfrm>
           <a:prstGeom prst="rect">
@@ -7130,7 +7070,7 @@
                   <a:schemeClr val="tx1"/>
                 </a:solidFill>
               </a:rPr>
-              <a:t>Le concept et les chapitres</a:t>
+              <a:t>Vous suivez le groupe</a:t>
             </a:r>
             <a:endParaRPr lang="en-US" sz="2000" dirty="0"/>
           </a:p>
@@ -7144,7 +7084,7 @@
         </p:nvSpPr>
         <p:spPr>
           <a:xfrm>
-            <a:off x="1508760" y="1819656"/>
+            <a:off x="1508760" y="1956816"/>
             <a:ext cx="9875520" cy="292608"/>
           </a:xfrm>
           <a:prstGeom prst="rect">
@@ -7166,7 +7106,7 @@
                   <a:schemeClr val="tx2"/>
                 </a:solidFill>
               </a:rPr>
-              <a:t>Ce que chaque chapitre raconte</a:t>
+              <a:t>Chaque étape vue en classe se fait dans votre projet, au même rythme</a:t>
             </a:r>
             <a:endParaRPr lang="en-US" sz="1400" dirty="0"/>
           </a:p>
@@ -7180,7 +7120,7 @@
         </p:nvSpPr>
         <p:spPr>
           <a:xfrm>
-            <a:off x="731520" y="2286000"/>
+            <a:off x="731520" y="2697480"/>
             <a:ext cx="566928" cy="566928"/>
           </a:xfrm>
           <a:prstGeom prst="ellipse">
@@ -7205,7 +7145,7 @@
         </p:nvSpPr>
         <p:spPr>
           <a:xfrm>
-            <a:off x="731520" y="2286000"/>
+            <a:off x="731520" y="2697480"/>
             <a:ext cx="566928" cy="566928"/>
           </a:xfrm>
           <a:prstGeom prst="rect">
@@ -7241,7 +7181,7 @@
         </p:nvSpPr>
         <p:spPr>
           <a:xfrm>
-            <a:off x="1508760" y="2249424"/>
+            <a:off x="1508760" y="2660904"/>
             <a:ext cx="9875520" cy="365760"/>
           </a:xfrm>
           <a:prstGeom prst="rect">
@@ -7263,7 +7203,7 @@
                   <a:schemeClr val="tx1"/>
                 </a:solidFill>
               </a:rPr>
-              <a:t>Le storyboard dans Figma</a:t>
+              <a:t>Vous me présentez chaque étape</a:t>
             </a:r>
             <a:endParaRPr lang="en-US" sz="2000" dirty="0"/>
           </a:p>
@@ -7277,7 +7217,7 @@
         </p:nvSpPr>
         <p:spPr>
           <a:xfrm>
-            <a:off x="1508760" y="2596896"/>
+            <a:off x="1508760" y="3008376"/>
             <a:ext cx="9875520" cy="292608"/>
           </a:xfrm>
           <a:prstGeom prst="rect">
@@ -7299,7 +7239,7 @@
                   <a:schemeClr val="tx2"/>
                 </a:solidFill>
               </a:rPr>
-              <a:t>Un cadre par chapitre, annoté</a:t>
+              <a:t>Cahier de charges, storyboard, animations, Vue, prototype, bêta</a:t>
             </a:r>
             <a:endParaRPr lang="en-US" sz="1400" dirty="0"/>
           </a:p>
@@ -7313,7 +7253,7 @@
         </p:nvSpPr>
         <p:spPr>
           <a:xfrm>
-            <a:off x="731520" y="3063240"/>
+            <a:off x="731520" y="3749040"/>
             <a:ext cx="566928" cy="566928"/>
           </a:xfrm>
           <a:prstGeom prst="ellipse">
@@ -7338,7 +7278,7 @@
         </p:nvSpPr>
         <p:spPr>
           <a:xfrm>
-            <a:off x="731520" y="3063240"/>
+            <a:off x="731520" y="3749040"/>
             <a:ext cx="566928" cy="566928"/>
           </a:xfrm>
           <a:prstGeom prst="rect">
@@ -7374,7 +7314,7 @@
         </p:nvSpPr>
         <p:spPr>
           <a:xfrm>
-            <a:off x="1508760" y="3026664"/>
+            <a:off x="1508760" y="3712464"/>
             <a:ext cx="9875520" cy="365760"/>
           </a:xfrm>
           <a:prstGeom prst="rect">
@@ -7396,7 +7336,7 @@
                   <a:schemeClr val="tx1"/>
                 </a:solidFill>
               </a:rPr>
-              <a:t>La matrice de responsabilités</a:t>
+              <a:t>Une étape sautée est à recommencer</a:t>
             </a:r>
             <a:endParaRPr lang="en-US" sz="2000" dirty="0"/>
           </a:p>
@@ -7410,7 +7350,7 @@
         </p:nvSpPr>
         <p:spPr>
           <a:xfrm>
-            <a:off x="1508760" y="3374136"/>
+            <a:off x="1508760" y="4059936"/>
             <a:ext cx="9875520" cy="292608"/>
           </a:xfrm>
           <a:prstGeom prst="rect">
@@ -7432,7 +7372,7 @@
                   <a:schemeClr val="tx2"/>
                 </a:solidFill>
               </a:rPr>
-              <a:t>Qui possède quoi, ensemble</a:t>
+              <a:t>Code généré d'un coup, sans planification ni compréhension : on refait</a:t>
             </a:r>
             <a:endParaRPr lang="en-US" sz="1400" dirty="0"/>
           </a:p>
@@ -7440,75 +7380,14 @@
       </p:sp>
       <p:sp>
         <p:nvSpPr>
-          <p:cNvPr id="15" name="etape-3"/>
-          <p:cNvSpPr/>
-          <p:nvPr/>
-        </p:nvSpPr>
-        <p:spPr>
-          <a:xfrm>
-            <a:off x="731520" y="3840480"/>
-            <a:ext cx="566928" cy="566928"/>
-          </a:xfrm>
-          <a:prstGeom prst="ellipse">
-            <a:avLst/>
-          </a:prstGeom>
-          <a:solidFill>
-            <a:schemeClr val="accent1"/>
-          </a:solidFill>
-          <a:ln w="12700">
-            <a:solidFill>
-              <a:schemeClr val="accent1"/>
-            </a:solidFill>
-            <a:prstDash val="solid"/>
-          </a:ln>
-        </p:spPr>
-      </p:sp>
-      <p:sp>
-        <p:nvSpPr>
-          <p:cNvPr id="16" name="Text 14"/>
-          <p:cNvSpPr txBox="1"/>
-          <p:nvPr/>
-        </p:nvSpPr>
-        <p:spPr>
-          <a:xfrm>
-            <a:off x="731520" y="3840480"/>
-            <a:ext cx="566928" cy="566928"/>
-          </a:xfrm>
-          <a:prstGeom prst="rect">
-            <a:avLst/>
-          </a:prstGeom>
-          <a:noFill/>
-          <a:ln/>
-        </p:spPr>
-        <p:txBody>
-          <a:bodyPr wrap="square" lIns="0" tIns="0" rIns="0" bIns="0" rtlCol="0" anchor="ctr"/>
-          <a:lstStyle/>
-          <a:p>
-            <a:pPr algn="ctr" indent="0" marL="0">
-              <a:buNone/>
-            </a:pPr>
-            <a:r>
-              <a:rPr lang="en-US" sz="2000" b="1" dirty="0">
-                <a:solidFill>
-                  <a:schemeClr val="bg1"/>
-                </a:solidFill>
-              </a:rPr>
-              <a:t>4</a:t>
-            </a:r>
-            <a:endParaRPr lang="en-US" sz="2000" dirty="0"/>
-          </a:p>
-        </p:txBody>
-      </p:sp>
-      <p:sp>
-        <p:nvSpPr>
-          <p:cNvPr id="17" name="Text 15"/>
-          <p:cNvSpPr txBox="1"/>
-          <p:nvPr/>
-        </p:nvSpPr>
-        <p:spPr>
-          <a:xfrm>
-            <a:off x="1508760" y="3803904"/>
-            <a:ext cx="9875520" cy="365760"/>
+          <p:cNvPr id="15" name="Text 13"/>
+          <p:cNvSpPr txBox="1"/>
+          <p:nvPr/>
+        </p:nvSpPr>
+        <p:spPr>
+          <a:xfrm>
+            <a:off x="731520" y="5074920"/>
+            <a:ext cx="10698480" cy="548640"/>
           </a:xfrm>
           <a:prstGeom prst="rect">
             <a:avLst/>
@@ -7524,316 +7403,25 @@
               <a:buNone/>
             </a:pPr>
             <a:r>
-              <a:rPr lang="en-US" sz="2000" b="1" dirty="0">
-                <a:solidFill>
-                  <a:schemeClr val="tx1"/>
-                </a:solidFill>
-              </a:rPr>
-              <a:t>Votre média animable</a:t>
-            </a:r>
-            <a:endParaRPr lang="en-US" sz="2000" dirty="0"/>
-          </a:p>
-        </p:txBody>
-      </p:sp>
-      <p:sp>
-        <p:nvSpPr>
-          <p:cNvPr id="18" name="Text 16"/>
-          <p:cNvSpPr txBox="1"/>
-          <p:nvPr/>
-        </p:nvSpPr>
-        <p:spPr>
-          <a:xfrm>
-            <a:off x="1508760" y="4151376"/>
-            <a:ext cx="9875520" cy="292608"/>
-          </a:xfrm>
-          <a:prstGeom prst="rect">
-            <a:avLst/>
-          </a:prstGeom>
-          <a:noFill/>
-          <a:ln/>
-        </p:spPr>
-        <p:txBody>
-          <a:bodyPr wrap="square" lIns="0" tIns="0" rIns="0" bIns="0" rtlCol="0" anchor="ctr"/>
-          <a:lstStyle/>
-          <a:p>
+              <a:rPr lang="en-US" sz="2200" b="1" dirty="0">
+                <a:solidFill>
+                  <a:schemeClr val="accent1"/>
+                </a:solidFill>
+              </a:rPr>
+              <a:t>Pas de passe-droit. </a:t>
+            </a:r>
             <a:pPr indent="0" marL="0">
               <a:buNone/>
             </a:pPr>
             <a:r>
-              <a:rPr lang="en-US" sz="1400" dirty="0">
+              <a:rPr lang="en-US" sz="2200" b="1" dirty="0">
                 <a:solidFill>
                   <a:schemeClr val="tx2"/>
                 </a:solidFill>
               </a:rPr>
-              <a:t>Calques, spritesheet ou SVG</a:t>
-            </a:r>
-            <a:endParaRPr lang="en-US" sz="1400" dirty="0"/>
-          </a:p>
-        </p:txBody>
-      </p:sp>
-      <p:sp>
-        <p:nvSpPr>
-          <p:cNvPr id="19" name="etape-4"/>
-          <p:cNvSpPr/>
-          <p:nvPr/>
-        </p:nvSpPr>
-        <p:spPr>
-          <a:xfrm>
-            <a:off x="731520" y="4617720"/>
-            <a:ext cx="566928" cy="566928"/>
-          </a:xfrm>
-          <a:prstGeom prst="ellipse">
-            <a:avLst/>
-          </a:prstGeom>
-          <a:solidFill>
-            <a:schemeClr val="accent1"/>
-          </a:solidFill>
-          <a:ln w="12700">
-            <a:solidFill>
-              <a:schemeClr val="accent1"/>
-            </a:solidFill>
-            <a:prstDash val="solid"/>
-          </a:ln>
-        </p:spPr>
-      </p:sp>
-      <p:sp>
-        <p:nvSpPr>
-          <p:cNvPr id="20" name="Text 18"/>
-          <p:cNvSpPr txBox="1"/>
-          <p:nvPr/>
-        </p:nvSpPr>
-        <p:spPr>
-          <a:xfrm>
-            <a:off x="731520" y="4617720"/>
-            <a:ext cx="566928" cy="566928"/>
-          </a:xfrm>
-          <a:prstGeom prst="rect">
-            <a:avLst/>
-          </a:prstGeom>
-          <a:noFill/>
-          <a:ln/>
-        </p:spPr>
-        <p:txBody>
-          <a:bodyPr wrap="square" lIns="0" tIns="0" rIns="0" bIns="0" rtlCol="0" anchor="ctr"/>
-          <a:lstStyle/>
-          <a:p>
-            <a:pPr algn="ctr" indent="0" marL="0">
-              <a:buNone/>
-            </a:pPr>
-            <a:r>
-              <a:rPr lang="en-US" sz="2000" b="1" dirty="0">
-                <a:solidFill>
-                  <a:schemeClr val="bg1"/>
-                </a:solidFill>
-              </a:rPr>
-              <a:t>5</a:t>
-            </a:r>
-            <a:endParaRPr lang="en-US" sz="2000" dirty="0"/>
-          </a:p>
-        </p:txBody>
-      </p:sp>
-      <p:sp>
-        <p:nvSpPr>
-          <p:cNvPr id="21" name="Text 19"/>
-          <p:cNvSpPr txBox="1"/>
-          <p:nvPr/>
-        </p:nvSpPr>
-        <p:spPr>
-          <a:xfrm>
-            <a:off x="1508760" y="4581144"/>
-            <a:ext cx="9875520" cy="365760"/>
-          </a:xfrm>
-          <a:prstGeom prst="rect">
-            <a:avLst/>
-          </a:prstGeom>
-          <a:noFill/>
-          <a:ln/>
-        </p:spPr>
-        <p:txBody>
-          <a:bodyPr wrap="square" lIns="0" tIns="0" rIns="0" bIns="0" rtlCol="0" anchor="ctr"/>
-          <a:lstStyle/>
-          <a:p>
-            <a:pPr indent="0" marL="0">
-              <a:buNone/>
-            </a:pPr>
-            <a:r>
-              <a:rPr lang="en-US" sz="2000" b="1" dirty="0">
-                <a:solidFill>
-                  <a:schemeClr val="tx1"/>
-                </a:solidFill>
-              </a:rPr>
-              <a:t>L'API de la dataviz</a:t>
-            </a:r>
-            <a:endParaRPr lang="en-US" sz="2000" dirty="0"/>
-          </a:p>
-        </p:txBody>
-      </p:sp>
-      <p:sp>
-        <p:nvSpPr>
-          <p:cNvPr id="22" name="Text 20"/>
-          <p:cNvSpPr txBox="1"/>
-          <p:nvPr/>
-        </p:nvSpPr>
-        <p:spPr>
-          <a:xfrm>
-            <a:off x="1508760" y="4928616"/>
-            <a:ext cx="9875520" cy="292608"/>
-          </a:xfrm>
-          <a:prstGeom prst="rect">
-            <a:avLst/>
-          </a:prstGeom>
-          <a:noFill/>
-          <a:ln/>
-        </p:spPr>
-        <p:txBody>
-          <a:bodyPr wrap="square" lIns="0" tIns="0" rIns="0" bIns="0" rtlCol="0" anchor="ctr"/>
-          <a:lstStyle/>
-          <a:p>
-            <a:pPr indent="0" marL="0">
-              <a:buNone/>
-            </a:pPr>
-            <a:r>
-              <a:rPr lang="en-US" sz="1400" dirty="0">
-                <a:solidFill>
-                  <a:schemeClr val="tx2"/>
-                </a:solidFill>
-              </a:rPr>
-              <a:t>Trouvée et testée dans la console</a:t>
-            </a:r>
-            <a:endParaRPr lang="en-US" sz="1400" dirty="0"/>
-          </a:p>
-        </p:txBody>
-      </p:sp>
-      <p:sp>
-        <p:nvSpPr>
-          <p:cNvPr id="23" name="etape-5"/>
-          <p:cNvSpPr/>
-          <p:nvPr/>
-        </p:nvSpPr>
-        <p:spPr>
-          <a:xfrm>
-            <a:off x="731520" y="5394960"/>
-            <a:ext cx="566928" cy="566928"/>
-          </a:xfrm>
-          <a:prstGeom prst="ellipse">
-            <a:avLst/>
-          </a:prstGeom>
-          <a:solidFill>
-            <a:schemeClr val="accent1"/>
-          </a:solidFill>
-          <a:ln w="12700">
-            <a:solidFill>
-              <a:schemeClr val="accent1"/>
-            </a:solidFill>
-            <a:prstDash val="solid"/>
-          </a:ln>
-        </p:spPr>
-      </p:sp>
-      <p:sp>
-        <p:nvSpPr>
-          <p:cNvPr id="24" name="Text 22"/>
-          <p:cNvSpPr txBox="1"/>
-          <p:nvPr/>
-        </p:nvSpPr>
-        <p:spPr>
-          <a:xfrm>
-            <a:off x="731520" y="5394960"/>
-            <a:ext cx="566928" cy="566928"/>
-          </a:xfrm>
-          <a:prstGeom prst="rect">
-            <a:avLst/>
-          </a:prstGeom>
-          <a:noFill/>
-          <a:ln/>
-        </p:spPr>
-        <p:txBody>
-          <a:bodyPr wrap="square" lIns="0" tIns="0" rIns="0" bIns="0" rtlCol="0" anchor="ctr"/>
-          <a:lstStyle/>
-          <a:p>
-            <a:pPr algn="ctr" indent="0" marL="0">
-              <a:buNone/>
-            </a:pPr>
-            <a:r>
-              <a:rPr lang="en-US" sz="2000" b="1" dirty="0">
-                <a:solidFill>
-                  <a:schemeClr val="bg1"/>
-                </a:solidFill>
-              </a:rPr>
-              <a:t>6</a:t>
-            </a:r>
-            <a:endParaRPr lang="en-US" sz="2000" dirty="0"/>
-          </a:p>
-        </p:txBody>
-      </p:sp>
-      <p:sp>
-        <p:nvSpPr>
-          <p:cNvPr id="25" name="Text 23"/>
-          <p:cNvSpPr txBox="1"/>
-          <p:nvPr/>
-        </p:nvSpPr>
-        <p:spPr>
-          <a:xfrm>
-            <a:off x="1508760" y="5358384"/>
-            <a:ext cx="9875520" cy="365760"/>
-          </a:xfrm>
-          <a:prstGeom prst="rect">
-            <a:avLst/>
-          </a:prstGeom>
-          <a:noFill/>
-          <a:ln/>
-        </p:spPr>
-        <p:txBody>
-          <a:bodyPr wrap="square" lIns="0" tIns="0" rIns="0" bIns="0" rtlCol="0" anchor="ctr"/>
-          <a:lstStyle/>
-          <a:p>
-            <a:pPr indent="0" marL="0">
-              <a:buNone/>
-            </a:pPr>
-            <a:r>
-              <a:rPr lang="en-US" sz="2000" b="1" dirty="0">
-                <a:solidFill>
-                  <a:schemeClr val="tx1"/>
-                </a:solidFill>
-              </a:rPr>
-              <a:t>Votre journal</a:t>
-            </a:r>
-            <a:endParaRPr lang="en-US" sz="2000" dirty="0"/>
-          </a:p>
-        </p:txBody>
-      </p:sp>
-      <p:sp>
-        <p:nvSpPr>
-          <p:cNvPr id="26" name="Text 24"/>
-          <p:cNvSpPr txBox="1"/>
-          <p:nvPr/>
-        </p:nvSpPr>
-        <p:spPr>
-          <a:xfrm>
-            <a:off x="1508760" y="5705856"/>
-            <a:ext cx="9875520" cy="292608"/>
-          </a:xfrm>
-          <a:prstGeom prst="rect">
-            <a:avLst/>
-          </a:prstGeom>
-          <a:noFill/>
-          <a:ln/>
-        </p:spPr>
-        <p:txBody>
-          <a:bodyPr wrap="square" lIns="0" tIns="0" rIns="0" bIns="0" rtlCol="0" anchor="ctr"/>
-          <a:lstStyle/>
-          <a:p>
-            <a:pPr indent="0" marL="0">
-              <a:buNone/>
-            </a:pPr>
-            <a:r>
-              <a:rPr lang="en-US" sz="1400" dirty="0">
-                <a:solidFill>
-                  <a:schemeClr val="tx2"/>
-                </a:solidFill>
-              </a:rPr>
-              <a:t>Un par personne</a:t>
-            </a:r>
-            <a:endParaRPr lang="en-US" sz="1400" dirty="0"/>
+              <a:t>L'IA : permise, documentée, comprise.</a:t>
+            </a:r>
+            <a:endParaRPr lang="en-US" sz="2200" dirty="0"/>
           </a:p>
         </p:txBody>
       </p:sp>
@@ -7917,8 +7505,8 @@
         </p:nvSpPr>
         <p:spPr>
           <a:xfrm>
-            <a:off x="731520" y="1828800"/>
-            <a:ext cx="10698480" cy="2377440"/>
+            <a:off x="731520" y="411480"/>
+            <a:ext cx="10698480" cy="822960"/>
           </a:xfrm>
           <a:prstGeom prst="rect">
             <a:avLst/>
@@ -7934,49 +7522,124 @@
               <a:buNone/>
             </a:pPr>
             <a:r>
-              <a:rPr lang="en-US" sz="6000" b="1" dirty="0">
+              <a:rPr lang="en-US" sz="3200" b="1" dirty="0">
                 <a:solidFill>
                   <a:schemeClr val="tx1"/>
                 </a:solidFill>
               </a:rPr>
-              <a:t>Pas encore de </a:t>
-            </a:r>
-            <a:pPr algn="l" indent="0" marL="0">
-              <a:buNone/>
-            </a:pPr>
-            <a:r>
-              <a:rPr lang="en-US" sz="6000" b="1" dirty="0">
-                <a:solidFill>
-                  <a:schemeClr val="accent1"/>
-                </a:solidFill>
-              </a:rPr>
-              <a:t>code d'animation</a:t>
-            </a:r>
-            <a:pPr algn="l" indent="0" marL="0">
-              <a:buNone/>
-            </a:pPr>
-            <a:r>
-              <a:rPr lang="en-US" sz="6000" b="1" dirty="0">
+              <a:t>Vos deux prochaines semaines</a:t>
+            </a:r>
+            <a:endParaRPr lang="en-US" sz="3200" dirty="0"/>
+          </a:p>
+        </p:txBody>
+      </p:sp>
+      <p:sp>
+        <p:nvSpPr>
+          <p:cNvPr id="3" name="etape-0"/>
+          <p:cNvSpPr/>
+          <p:nvPr/>
+        </p:nvSpPr>
+        <p:spPr>
+          <a:xfrm>
+            <a:off x="731520" y="1508760"/>
+            <a:ext cx="566928" cy="566928"/>
+          </a:xfrm>
+          <a:prstGeom prst="ellipse">
+            <a:avLst/>
+          </a:prstGeom>
+          <a:solidFill>
+            <a:schemeClr val="accent1"/>
+          </a:solidFill>
+          <a:ln w="12700">
+            <a:solidFill>
+              <a:schemeClr val="accent1"/>
+            </a:solidFill>
+            <a:prstDash val="solid"/>
+          </a:ln>
+        </p:spPr>
+      </p:sp>
+      <p:sp>
+        <p:nvSpPr>
+          <p:cNvPr id="4" name="Text 2"/>
+          <p:cNvSpPr txBox="1"/>
+          <p:nvPr/>
+        </p:nvSpPr>
+        <p:spPr>
+          <a:xfrm>
+            <a:off x="731520" y="1508760"/>
+            <a:ext cx="566928" cy="566928"/>
+          </a:xfrm>
+          <a:prstGeom prst="rect">
+            <a:avLst/>
+          </a:prstGeom>
+          <a:noFill/>
+          <a:ln/>
+        </p:spPr>
+        <p:txBody>
+          <a:bodyPr wrap="square" lIns="0" tIns="0" rIns="0" bIns="0" rtlCol="0" anchor="ctr"/>
+          <a:lstStyle/>
+          <a:p>
+            <a:pPr algn="ctr" indent="0" marL="0">
+              <a:buNone/>
+            </a:pPr>
+            <a:r>
+              <a:rPr lang="en-US" sz="2000" b="1" dirty="0">
+                <a:solidFill>
+                  <a:schemeClr val="bg1"/>
+                </a:solidFill>
+              </a:rPr>
+              <a:t>1</a:t>
+            </a:r>
+            <a:endParaRPr lang="en-US" sz="2000" dirty="0"/>
+          </a:p>
+        </p:txBody>
+      </p:sp>
+      <p:sp>
+        <p:nvSpPr>
+          <p:cNvPr id="5" name="Text 3"/>
+          <p:cNvSpPr txBox="1"/>
+          <p:nvPr/>
+        </p:nvSpPr>
+        <p:spPr>
+          <a:xfrm>
+            <a:off x="1508760" y="1472184"/>
+            <a:ext cx="9875520" cy="365760"/>
+          </a:xfrm>
+          <a:prstGeom prst="rect">
+            <a:avLst/>
+          </a:prstGeom>
+          <a:noFill/>
+          <a:ln/>
+        </p:spPr>
+        <p:txBody>
+          <a:bodyPr wrap="square" lIns="0" tIns="0" rIns="0" bIns="0" rtlCol="0" anchor="ctr"/>
+          <a:lstStyle/>
+          <a:p>
+            <a:pPr indent="0" marL="0">
+              <a:buNone/>
+            </a:pPr>
+            <a:r>
+              <a:rPr lang="en-US" sz="2000" b="1" dirty="0">
                 <a:solidFill>
                   <a:schemeClr val="tx1"/>
                 </a:solidFill>
               </a:rPr>
-              <a:t>.</a:t>
-            </a:r>
-            <a:endParaRPr lang="en-US" sz="6000" dirty="0"/>
-          </a:p>
-        </p:txBody>
-      </p:sp>
-      <p:sp>
-        <p:nvSpPr>
-          <p:cNvPr id="3" name="kicker"/>
-          <p:cNvSpPr txBox="1"/>
-          <p:nvPr/>
-        </p:nvSpPr>
-        <p:spPr>
-          <a:xfrm>
-            <a:off x="731520" y="1463040"/>
-            <a:ext cx="10698480" cy="365760"/>
+              <a:t>Le concept et les chapitres</a:t>
+            </a:r>
+            <a:endParaRPr lang="en-US" sz="2000" dirty="0"/>
+          </a:p>
+        </p:txBody>
+      </p:sp>
+      <p:sp>
+        <p:nvSpPr>
+          <p:cNvPr id="6" name="Text 4"/>
+          <p:cNvSpPr txBox="1"/>
+          <p:nvPr/>
+        </p:nvSpPr>
+        <p:spPr>
+          <a:xfrm>
+            <a:off x="1508760" y="1819656"/>
+            <a:ext cx="9875520" cy="292608"/>
           </a:xfrm>
           <a:prstGeom prst="rect">
             <a:avLst/>
@@ -7992,14 +7655,679 @@
               <a:buNone/>
             </a:pPr>
             <a:r>
-              <a:rPr lang="en-US" sz="1300" spc="400" kern="0" dirty="0">
+              <a:rPr lang="en-US" sz="1400" dirty="0">
                 <a:solidFill>
                   <a:schemeClr val="tx2"/>
                 </a:solidFill>
               </a:rPr>
-              <a:t>D'ICI LE 23 OCTOBRE : LA CONCEPTION</a:t>
-            </a:r>
-            <a:endParaRPr lang="en-US" sz="1300" dirty="0"/>
+              <a:t>Ce que chaque chapitre raconte</a:t>
+            </a:r>
+            <a:endParaRPr lang="en-US" sz="1400" dirty="0"/>
+          </a:p>
+        </p:txBody>
+      </p:sp>
+      <p:sp>
+        <p:nvSpPr>
+          <p:cNvPr id="7" name="etape-1"/>
+          <p:cNvSpPr/>
+          <p:nvPr/>
+        </p:nvSpPr>
+        <p:spPr>
+          <a:xfrm>
+            <a:off x="731520" y="2286000"/>
+            <a:ext cx="566928" cy="566928"/>
+          </a:xfrm>
+          <a:prstGeom prst="ellipse">
+            <a:avLst/>
+          </a:prstGeom>
+          <a:solidFill>
+            <a:schemeClr val="accent1"/>
+          </a:solidFill>
+          <a:ln w="12700">
+            <a:solidFill>
+              <a:schemeClr val="accent1"/>
+            </a:solidFill>
+            <a:prstDash val="solid"/>
+          </a:ln>
+        </p:spPr>
+      </p:sp>
+      <p:sp>
+        <p:nvSpPr>
+          <p:cNvPr id="8" name="Text 6"/>
+          <p:cNvSpPr txBox="1"/>
+          <p:nvPr/>
+        </p:nvSpPr>
+        <p:spPr>
+          <a:xfrm>
+            <a:off x="731520" y="2286000"/>
+            <a:ext cx="566928" cy="566928"/>
+          </a:xfrm>
+          <a:prstGeom prst="rect">
+            <a:avLst/>
+          </a:prstGeom>
+          <a:noFill/>
+          <a:ln/>
+        </p:spPr>
+        <p:txBody>
+          <a:bodyPr wrap="square" lIns="0" tIns="0" rIns="0" bIns="0" rtlCol="0" anchor="ctr"/>
+          <a:lstStyle/>
+          <a:p>
+            <a:pPr algn="ctr" indent="0" marL="0">
+              <a:buNone/>
+            </a:pPr>
+            <a:r>
+              <a:rPr lang="en-US" sz="2000" b="1" dirty="0">
+                <a:solidFill>
+                  <a:schemeClr val="bg1"/>
+                </a:solidFill>
+              </a:rPr>
+              <a:t>2</a:t>
+            </a:r>
+            <a:endParaRPr lang="en-US" sz="2000" dirty="0"/>
+          </a:p>
+        </p:txBody>
+      </p:sp>
+      <p:sp>
+        <p:nvSpPr>
+          <p:cNvPr id="9" name="Text 7"/>
+          <p:cNvSpPr txBox="1"/>
+          <p:nvPr/>
+        </p:nvSpPr>
+        <p:spPr>
+          <a:xfrm>
+            <a:off x="1508760" y="2249424"/>
+            <a:ext cx="9875520" cy="365760"/>
+          </a:xfrm>
+          <a:prstGeom prst="rect">
+            <a:avLst/>
+          </a:prstGeom>
+          <a:noFill/>
+          <a:ln/>
+        </p:spPr>
+        <p:txBody>
+          <a:bodyPr wrap="square" lIns="0" tIns="0" rIns="0" bIns="0" rtlCol="0" anchor="ctr"/>
+          <a:lstStyle/>
+          <a:p>
+            <a:pPr indent="0" marL="0">
+              <a:buNone/>
+            </a:pPr>
+            <a:r>
+              <a:rPr lang="en-US" sz="2000" b="1" dirty="0">
+                <a:solidFill>
+                  <a:schemeClr val="tx1"/>
+                </a:solidFill>
+              </a:rPr>
+              <a:t>Le storyboard dans Figma</a:t>
+            </a:r>
+            <a:endParaRPr lang="en-US" sz="2000" dirty="0"/>
+          </a:p>
+        </p:txBody>
+      </p:sp>
+      <p:sp>
+        <p:nvSpPr>
+          <p:cNvPr id="10" name="Text 8"/>
+          <p:cNvSpPr txBox="1"/>
+          <p:nvPr/>
+        </p:nvSpPr>
+        <p:spPr>
+          <a:xfrm>
+            <a:off x="1508760" y="2596896"/>
+            <a:ext cx="9875520" cy="292608"/>
+          </a:xfrm>
+          <a:prstGeom prst="rect">
+            <a:avLst/>
+          </a:prstGeom>
+          <a:noFill/>
+          <a:ln/>
+        </p:spPr>
+        <p:txBody>
+          <a:bodyPr wrap="square" lIns="0" tIns="0" rIns="0" bIns="0" rtlCol="0" anchor="ctr"/>
+          <a:lstStyle/>
+          <a:p>
+            <a:pPr indent="0" marL="0">
+              <a:buNone/>
+            </a:pPr>
+            <a:r>
+              <a:rPr lang="en-US" sz="1400" dirty="0">
+                <a:solidFill>
+                  <a:schemeClr val="tx2"/>
+                </a:solidFill>
+              </a:rPr>
+              <a:t>Un cadre par chapitre, annoté</a:t>
+            </a:r>
+            <a:endParaRPr lang="en-US" sz="1400" dirty="0"/>
+          </a:p>
+        </p:txBody>
+      </p:sp>
+      <p:sp>
+        <p:nvSpPr>
+          <p:cNvPr id="11" name="etape-2"/>
+          <p:cNvSpPr/>
+          <p:nvPr/>
+        </p:nvSpPr>
+        <p:spPr>
+          <a:xfrm>
+            <a:off x="731520" y="3063240"/>
+            <a:ext cx="566928" cy="566928"/>
+          </a:xfrm>
+          <a:prstGeom prst="ellipse">
+            <a:avLst/>
+          </a:prstGeom>
+          <a:solidFill>
+            <a:schemeClr val="accent1"/>
+          </a:solidFill>
+          <a:ln w="12700">
+            <a:solidFill>
+              <a:schemeClr val="accent1"/>
+            </a:solidFill>
+            <a:prstDash val="solid"/>
+          </a:ln>
+        </p:spPr>
+      </p:sp>
+      <p:sp>
+        <p:nvSpPr>
+          <p:cNvPr id="12" name="Text 10"/>
+          <p:cNvSpPr txBox="1"/>
+          <p:nvPr/>
+        </p:nvSpPr>
+        <p:spPr>
+          <a:xfrm>
+            <a:off x="731520" y="3063240"/>
+            <a:ext cx="566928" cy="566928"/>
+          </a:xfrm>
+          <a:prstGeom prst="rect">
+            <a:avLst/>
+          </a:prstGeom>
+          <a:noFill/>
+          <a:ln/>
+        </p:spPr>
+        <p:txBody>
+          <a:bodyPr wrap="square" lIns="0" tIns="0" rIns="0" bIns="0" rtlCol="0" anchor="ctr"/>
+          <a:lstStyle/>
+          <a:p>
+            <a:pPr algn="ctr" indent="0" marL="0">
+              <a:buNone/>
+            </a:pPr>
+            <a:r>
+              <a:rPr lang="en-US" sz="2000" b="1" dirty="0">
+                <a:solidFill>
+                  <a:schemeClr val="bg1"/>
+                </a:solidFill>
+              </a:rPr>
+              <a:t>3</a:t>
+            </a:r>
+            <a:endParaRPr lang="en-US" sz="2000" dirty="0"/>
+          </a:p>
+        </p:txBody>
+      </p:sp>
+      <p:sp>
+        <p:nvSpPr>
+          <p:cNvPr id="13" name="Text 11"/>
+          <p:cNvSpPr txBox="1"/>
+          <p:nvPr/>
+        </p:nvSpPr>
+        <p:spPr>
+          <a:xfrm>
+            <a:off x="1508760" y="3026664"/>
+            <a:ext cx="9875520" cy="365760"/>
+          </a:xfrm>
+          <a:prstGeom prst="rect">
+            <a:avLst/>
+          </a:prstGeom>
+          <a:noFill/>
+          <a:ln/>
+        </p:spPr>
+        <p:txBody>
+          <a:bodyPr wrap="square" lIns="0" tIns="0" rIns="0" bIns="0" rtlCol="0" anchor="ctr"/>
+          <a:lstStyle/>
+          <a:p>
+            <a:pPr indent="0" marL="0">
+              <a:buNone/>
+            </a:pPr>
+            <a:r>
+              <a:rPr lang="en-US" sz="2000" b="1" dirty="0">
+                <a:solidFill>
+                  <a:schemeClr val="tx1"/>
+                </a:solidFill>
+              </a:rPr>
+              <a:t>La matrice de responsabilités</a:t>
+            </a:r>
+            <a:endParaRPr lang="en-US" sz="2000" dirty="0"/>
+          </a:p>
+        </p:txBody>
+      </p:sp>
+      <p:sp>
+        <p:nvSpPr>
+          <p:cNvPr id="14" name="Text 12"/>
+          <p:cNvSpPr txBox="1"/>
+          <p:nvPr/>
+        </p:nvSpPr>
+        <p:spPr>
+          <a:xfrm>
+            <a:off x="1508760" y="3374136"/>
+            <a:ext cx="9875520" cy="292608"/>
+          </a:xfrm>
+          <a:prstGeom prst="rect">
+            <a:avLst/>
+          </a:prstGeom>
+          <a:noFill/>
+          <a:ln/>
+        </p:spPr>
+        <p:txBody>
+          <a:bodyPr wrap="square" lIns="0" tIns="0" rIns="0" bIns="0" rtlCol="0" anchor="ctr"/>
+          <a:lstStyle/>
+          <a:p>
+            <a:pPr indent="0" marL="0">
+              <a:buNone/>
+            </a:pPr>
+            <a:r>
+              <a:rPr lang="en-US" sz="1400" dirty="0">
+                <a:solidFill>
+                  <a:schemeClr val="tx2"/>
+                </a:solidFill>
+              </a:rPr>
+              <a:t>Qui possède quoi, ensemble</a:t>
+            </a:r>
+            <a:endParaRPr lang="en-US" sz="1400" dirty="0"/>
+          </a:p>
+        </p:txBody>
+      </p:sp>
+      <p:sp>
+        <p:nvSpPr>
+          <p:cNvPr id="15" name="etape-3"/>
+          <p:cNvSpPr/>
+          <p:nvPr/>
+        </p:nvSpPr>
+        <p:spPr>
+          <a:xfrm>
+            <a:off x="731520" y="3840480"/>
+            <a:ext cx="566928" cy="566928"/>
+          </a:xfrm>
+          <a:prstGeom prst="ellipse">
+            <a:avLst/>
+          </a:prstGeom>
+          <a:solidFill>
+            <a:schemeClr val="accent1"/>
+          </a:solidFill>
+          <a:ln w="12700">
+            <a:solidFill>
+              <a:schemeClr val="accent1"/>
+            </a:solidFill>
+            <a:prstDash val="solid"/>
+          </a:ln>
+        </p:spPr>
+      </p:sp>
+      <p:sp>
+        <p:nvSpPr>
+          <p:cNvPr id="16" name="Text 14"/>
+          <p:cNvSpPr txBox="1"/>
+          <p:nvPr/>
+        </p:nvSpPr>
+        <p:spPr>
+          <a:xfrm>
+            <a:off x="731520" y="3840480"/>
+            <a:ext cx="566928" cy="566928"/>
+          </a:xfrm>
+          <a:prstGeom prst="rect">
+            <a:avLst/>
+          </a:prstGeom>
+          <a:noFill/>
+          <a:ln/>
+        </p:spPr>
+        <p:txBody>
+          <a:bodyPr wrap="square" lIns="0" tIns="0" rIns="0" bIns="0" rtlCol="0" anchor="ctr"/>
+          <a:lstStyle/>
+          <a:p>
+            <a:pPr algn="ctr" indent="0" marL="0">
+              <a:buNone/>
+            </a:pPr>
+            <a:r>
+              <a:rPr lang="en-US" sz="2000" b="1" dirty="0">
+                <a:solidFill>
+                  <a:schemeClr val="bg1"/>
+                </a:solidFill>
+              </a:rPr>
+              <a:t>4</a:t>
+            </a:r>
+            <a:endParaRPr lang="en-US" sz="2000" dirty="0"/>
+          </a:p>
+        </p:txBody>
+      </p:sp>
+      <p:sp>
+        <p:nvSpPr>
+          <p:cNvPr id="17" name="Text 15"/>
+          <p:cNvSpPr txBox="1"/>
+          <p:nvPr/>
+        </p:nvSpPr>
+        <p:spPr>
+          <a:xfrm>
+            <a:off x="1508760" y="3803904"/>
+            <a:ext cx="9875520" cy="365760"/>
+          </a:xfrm>
+          <a:prstGeom prst="rect">
+            <a:avLst/>
+          </a:prstGeom>
+          <a:noFill/>
+          <a:ln/>
+        </p:spPr>
+        <p:txBody>
+          <a:bodyPr wrap="square" lIns="0" tIns="0" rIns="0" bIns="0" rtlCol="0" anchor="ctr"/>
+          <a:lstStyle/>
+          <a:p>
+            <a:pPr indent="0" marL="0">
+              <a:buNone/>
+            </a:pPr>
+            <a:r>
+              <a:rPr lang="en-US" sz="2000" b="1" dirty="0">
+                <a:solidFill>
+                  <a:schemeClr val="tx1"/>
+                </a:solidFill>
+              </a:rPr>
+              <a:t>Votre média animable</a:t>
+            </a:r>
+            <a:endParaRPr lang="en-US" sz="2000" dirty="0"/>
+          </a:p>
+        </p:txBody>
+      </p:sp>
+      <p:sp>
+        <p:nvSpPr>
+          <p:cNvPr id="18" name="Text 16"/>
+          <p:cNvSpPr txBox="1"/>
+          <p:nvPr/>
+        </p:nvSpPr>
+        <p:spPr>
+          <a:xfrm>
+            <a:off x="1508760" y="4151376"/>
+            <a:ext cx="9875520" cy="292608"/>
+          </a:xfrm>
+          <a:prstGeom prst="rect">
+            <a:avLst/>
+          </a:prstGeom>
+          <a:noFill/>
+          <a:ln/>
+        </p:spPr>
+        <p:txBody>
+          <a:bodyPr wrap="square" lIns="0" tIns="0" rIns="0" bIns="0" rtlCol="0" anchor="ctr"/>
+          <a:lstStyle/>
+          <a:p>
+            <a:pPr indent="0" marL="0">
+              <a:buNone/>
+            </a:pPr>
+            <a:r>
+              <a:rPr lang="en-US" sz="1400" dirty="0">
+                <a:solidFill>
+                  <a:schemeClr val="tx2"/>
+                </a:solidFill>
+              </a:rPr>
+              <a:t>Calques, spritesheet ou SVG</a:t>
+            </a:r>
+            <a:endParaRPr lang="en-US" sz="1400" dirty="0"/>
+          </a:p>
+        </p:txBody>
+      </p:sp>
+      <p:sp>
+        <p:nvSpPr>
+          <p:cNvPr id="19" name="etape-4"/>
+          <p:cNvSpPr/>
+          <p:nvPr/>
+        </p:nvSpPr>
+        <p:spPr>
+          <a:xfrm>
+            <a:off x="731520" y="4617720"/>
+            <a:ext cx="566928" cy="566928"/>
+          </a:xfrm>
+          <a:prstGeom prst="ellipse">
+            <a:avLst/>
+          </a:prstGeom>
+          <a:solidFill>
+            <a:schemeClr val="accent1"/>
+          </a:solidFill>
+          <a:ln w="12700">
+            <a:solidFill>
+              <a:schemeClr val="accent1"/>
+            </a:solidFill>
+            <a:prstDash val="solid"/>
+          </a:ln>
+        </p:spPr>
+      </p:sp>
+      <p:sp>
+        <p:nvSpPr>
+          <p:cNvPr id="20" name="Text 18"/>
+          <p:cNvSpPr txBox="1"/>
+          <p:nvPr/>
+        </p:nvSpPr>
+        <p:spPr>
+          <a:xfrm>
+            <a:off x="731520" y="4617720"/>
+            <a:ext cx="566928" cy="566928"/>
+          </a:xfrm>
+          <a:prstGeom prst="rect">
+            <a:avLst/>
+          </a:prstGeom>
+          <a:noFill/>
+          <a:ln/>
+        </p:spPr>
+        <p:txBody>
+          <a:bodyPr wrap="square" lIns="0" tIns="0" rIns="0" bIns="0" rtlCol="0" anchor="ctr"/>
+          <a:lstStyle/>
+          <a:p>
+            <a:pPr algn="ctr" indent="0" marL="0">
+              <a:buNone/>
+            </a:pPr>
+            <a:r>
+              <a:rPr lang="en-US" sz="2000" b="1" dirty="0">
+                <a:solidFill>
+                  <a:schemeClr val="bg1"/>
+                </a:solidFill>
+              </a:rPr>
+              <a:t>5</a:t>
+            </a:r>
+            <a:endParaRPr lang="en-US" sz="2000" dirty="0"/>
+          </a:p>
+        </p:txBody>
+      </p:sp>
+      <p:sp>
+        <p:nvSpPr>
+          <p:cNvPr id="21" name="Text 19"/>
+          <p:cNvSpPr txBox="1"/>
+          <p:nvPr/>
+        </p:nvSpPr>
+        <p:spPr>
+          <a:xfrm>
+            <a:off x="1508760" y="4581144"/>
+            <a:ext cx="9875520" cy="365760"/>
+          </a:xfrm>
+          <a:prstGeom prst="rect">
+            <a:avLst/>
+          </a:prstGeom>
+          <a:noFill/>
+          <a:ln/>
+        </p:spPr>
+        <p:txBody>
+          <a:bodyPr wrap="square" lIns="0" tIns="0" rIns="0" bIns="0" rtlCol="0" anchor="ctr"/>
+          <a:lstStyle/>
+          <a:p>
+            <a:pPr indent="0" marL="0">
+              <a:buNone/>
+            </a:pPr>
+            <a:r>
+              <a:rPr lang="en-US" sz="2000" b="1" dirty="0">
+                <a:solidFill>
+                  <a:schemeClr val="tx1"/>
+                </a:solidFill>
+              </a:rPr>
+              <a:t>L'API de la dataviz</a:t>
+            </a:r>
+            <a:endParaRPr lang="en-US" sz="2000" dirty="0"/>
+          </a:p>
+        </p:txBody>
+      </p:sp>
+      <p:sp>
+        <p:nvSpPr>
+          <p:cNvPr id="22" name="Text 20"/>
+          <p:cNvSpPr txBox="1"/>
+          <p:nvPr/>
+        </p:nvSpPr>
+        <p:spPr>
+          <a:xfrm>
+            <a:off x="1508760" y="4928616"/>
+            <a:ext cx="9875520" cy="292608"/>
+          </a:xfrm>
+          <a:prstGeom prst="rect">
+            <a:avLst/>
+          </a:prstGeom>
+          <a:noFill/>
+          <a:ln/>
+        </p:spPr>
+        <p:txBody>
+          <a:bodyPr wrap="square" lIns="0" tIns="0" rIns="0" bIns="0" rtlCol="0" anchor="ctr"/>
+          <a:lstStyle/>
+          <a:p>
+            <a:pPr indent="0" marL="0">
+              <a:buNone/>
+            </a:pPr>
+            <a:r>
+              <a:rPr lang="en-US" sz="1400" dirty="0">
+                <a:solidFill>
+                  <a:schemeClr val="tx2"/>
+                </a:solidFill>
+              </a:rPr>
+              <a:t>Trouvée et testée dans la console</a:t>
+            </a:r>
+            <a:endParaRPr lang="en-US" sz="1400" dirty="0"/>
+          </a:p>
+        </p:txBody>
+      </p:sp>
+      <p:sp>
+        <p:nvSpPr>
+          <p:cNvPr id="23" name="etape-5"/>
+          <p:cNvSpPr/>
+          <p:nvPr/>
+        </p:nvSpPr>
+        <p:spPr>
+          <a:xfrm>
+            <a:off x="731520" y="5394960"/>
+            <a:ext cx="566928" cy="566928"/>
+          </a:xfrm>
+          <a:prstGeom prst="ellipse">
+            <a:avLst/>
+          </a:prstGeom>
+          <a:solidFill>
+            <a:schemeClr val="accent1"/>
+          </a:solidFill>
+          <a:ln w="12700">
+            <a:solidFill>
+              <a:schemeClr val="accent1"/>
+            </a:solidFill>
+            <a:prstDash val="solid"/>
+          </a:ln>
+        </p:spPr>
+      </p:sp>
+      <p:sp>
+        <p:nvSpPr>
+          <p:cNvPr id="24" name="Text 22"/>
+          <p:cNvSpPr txBox="1"/>
+          <p:nvPr/>
+        </p:nvSpPr>
+        <p:spPr>
+          <a:xfrm>
+            <a:off x="731520" y="5394960"/>
+            <a:ext cx="566928" cy="566928"/>
+          </a:xfrm>
+          <a:prstGeom prst="rect">
+            <a:avLst/>
+          </a:prstGeom>
+          <a:noFill/>
+          <a:ln/>
+        </p:spPr>
+        <p:txBody>
+          <a:bodyPr wrap="square" lIns="0" tIns="0" rIns="0" bIns="0" rtlCol="0" anchor="ctr"/>
+          <a:lstStyle/>
+          <a:p>
+            <a:pPr algn="ctr" indent="0" marL="0">
+              <a:buNone/>
+            </a:pPr>
+            <a:r>
+              <a:rPr lang="en-US" sz="2000" b="1" dirty="0">
+                <a:solidFill>
+                  <a:schemeClr val="bg1"/>
+                </a:solidFill>
+              </a:rPr>
+              <a:t>6</a:t>
+            </a:r>
+            <a:endParaRPr lang="en-US" sz="2000" dirty="0"/>
+          </a:p>
+        </p:txBody>
+      </p:sp>
+      <p:sp>
+        <p:nvSpPr>
+          <p:cNvPr id="25" name="Text 23"/>
+          <p:cNvSpPr txBox="1"/>
+          <p:nvPr/>
+        </p:nvSpPr>
+        <p:spPr>
+          <a:xfrm>
+            <a:off x="1508760" y="5358384"/>
+            <a:ext cx="9875520" cy="365760"/>
+          </a:xfrm>
+          <a:prstGeom prst="rect">
+            <a:avLst/>
+          </a:prstGeom>
+          <a:noFill/>
+          <a:ln/>
+        </p:spPr>
+        <p:txBody>
+          <a:bodyPr wrap="square" lIns="0" tIns="0" rIns="0" bIns="0" rtlCol="0" anchor="ctr"/>
+          <a:lstStyle/>
+          <a:p>
+            <a:pPr indent="0" marL="0">
+              <a:buNone/>
+            </a:pPr>
+            <a:r>
+              <a:rPr lang="en-US" sz="2000" b="1" dirty="0">
+                <a:solidFill>
+                  <a:schemeClr val="tx1"/>
+                </a:solidFill>
+              </a:rPr>
+              <a:t>Votre journal</a:t>
+            </a:r>
+            <a:endParaRPr lang="en-US" sz="2000" dirty="0"/>
+          </a:p>
+        </p:txBody>
+      </p:sp>
+      <p:sp>
+        <p:nvSpPr>
+          <p:cNvPr id="26" name="Text 24"/>
+          <p:cNvSpPr txBox="1"/>
+          <p:nvPr/>
+        </p:nvSpPr>
+        <p:spPr>
+          <a:xfrm>
+            <a:off x="1508760" y="5705856"/>
+            <a:ext cx="9875520" cy="292608"/>
+          </a:xfrm>
+          <a:prstGeom prst="rect">
+            <a:avLst/>
+          </a:prstGeom>
+          <a:noFill/>
+          <a:ln/>
+        </p:spPr>
+        <p:txBody>
+          <a:bodyPr wrap="square" lIns="0" tIns="0" rIns="0" bIns="0" rtlCol="0" anchor="ctr"/>
+          <a:lstStyle/>
+          <a:p>
+            <a:pPr indent="0" marL="0">
+              <a:buNone/>
+            </a:pPr>
+            <a:r>
+              <a:rPr lang="en-US" sz="1400" dirty="0">
+                <a:solidFill>
+                  <a:schemeClr val="tx2"/>
+                </a:solidFill>
+              </a:rPr>
+              <a:t>Un par personne</a:t>
+            </a:r>
+            <a:endParaRPr lang="en-US" sz="1400" dirty="0"/>
           </a:p>
         </p:txBody>
       </p:sp>
@@ -8083,8 +8411,8 @@
         </p:nvSpPr>
         <p:spPr>
           <a:xfrm>
-            <a:off x="731520" y="411480"/>
-            <a:ext cx="10698480" cy="822960"/>
+            <a:off x="731520" y="1828800"/>
+            <a:ext cx="10698480" cy="2377440"/>
           </a:xfrm>
           <a:prstGeom prst="rect">
             <a:avLst/>
@@ -8100,25 +8428,36 @@
               <a:buNone/>
             </a:pPr>
             <a:r>
-              <a:rPr lang="en-US" sz="3200" b="1" dirty="0">
+              <a:rPr lang="en-US" sz="6000" b="1" dirty="0">
                 <a:solidFill>
                   <a:schemeClr val="tx1"/>
                 </a:solidFill>
               </a:rPr>
-              <a:t>Remise 1 : </a:t>
+              <a:t>Pas encore de </a:t>
             </a:r>
             <a:pPr algn="l" indent="0" marL="0">
               <a:buNone/>
             </a:pPr>
             <a:r>
-              <a:rPr lang="en-US" sz="3200" b="1" dirty="0">
+              <a:rPr lang="en-US" sz="6000" b="1" dirty="0">
                 <a:solidFill>
                   <a:schemeClr val="accent1"/>
                 </a:solidFill>
               </a:rPr>
-              <a:t>ven. 23 oct.</a:t>
-            </a:r>
-            <a:endParaRPr lang="en-US" sz="3200" dirty="0"/>
+              <a:t>code d'animation</a:t>
+            </a:r>
+            <a:pPr algn="l" indent="0" marL="0">
+              <a:buNone/>
+            </a:pPr>
+            <a:r>
+              <a:rPr lang="en-US" sz="6000" b="1" dirty="0">
+                <a:solidFill>
+                  <a:schemeClr val="tx1"/>
+                </a:solidFill>
+              </a:rPr>
+              <a:t>.</a:t>
+            </a:r>
+            <a:endParaRPr lang="en-US" sz="6000" dirty="0"/>
           </a:p>
         </p:txBody>
       </p:sp>
@@ -8130,7 +8469,7 @@
         </p:nvSpPr>
         <p:spPr>
           <a:xfrm>
-            <a:off x="731520" y="1325880"/>
+            <a:off x="731520" y="1463040"/>
             <a:ext cx="10698480" cy="365760"/>
           </a:xfrm>
           <a:prstGeom prst="rect">
@@ -8152,541 +8491,9 @@
                   <a:schemeClr val="tx2"/>
                 </a:solidFill>
               </a:rPr>
-              <a:t>AU DÉBUT DU COURS</a:t>
+              <a:t>D'ICI LE 23 OCTOBRE : LA CONCEPTION</a:t>
             </a:r>
             <a:endParaRPr lang="en-US" sz="1300" dirty="0"/>
-          </a:p>
-        </p:txBody>
-      </p:sp>
-      <p:sp>
-        <p:nvSpPr>
-          <p:cNvPr id="4" name="etape-0"/>
-          <p:cNvSpPr/>
-          <p:nvPr/>
-        </p:nvSpPr>
-        <p:spPr>
-          <a:xfrm>
-            <a:off x="731520" y="1874520"/>
-            <a:ext cx="566928" cy="566928"/>
-          </a:xfrm>
-          <a:prstGeom prst="ellipse">
-            <a:avLst/>
-          </a:prstGeom>
-          <a:solidFill>
-            <a:schemeClr val="accent1"/>
-          </a:solidFill>
-          <a:ln w="12700">
-            <a:solidFill>
-              <a:schemeClr val="accent1"/>
-            </a:solidFill>
-            <a:prstDash val="solid"/>
-          </a:ln>
-        </p:spPr>
-      </p:sp>
-      <p:sp>
-        <p:nvSpPr>
-          <p:cNvPr id="5" name="Text 3"/>
-          <p:cNvSpPr txBox="1"/>
-          <p:nvPr/>
-        </p:nvSpPr>
-        <p:spPr>
-          <a:xfrm>
-            <a:off x="731520" y="1874520"/>
-            <a:ext cx="566928" cy="566928"/>
-          </a:xfrm>
-          <a:prstGeom prst="rect">
-            <a:avLst/>
-          </a:prstGeom>
-          <a:noFill/>
-          <a:ln/>
-        </p:spPr>
-        <p:txBody>
-          <a:bodyPr wrap="square" lIns="0" tIns="0" rIns="0" bIns="0" rtlCol="0" anchor="ctr"/>
-          <a:lstStyle/>
-          <a:p>
-            <a:pPr algn="ctr" indent="0" marL="0">
-              <a:buNone/>
-            </a:pPr>
-            <a:r>
-              <a:rPr lang="en-US" sz="2000" b="1" dirty="0">
-                <a:solidFill>
-                  <a:schemeClr val="bg1"/>
-                </a:solidFill>
-              </a:rPr>
-              <a:t>1</a:t>
-            </a:r>
-            <a:endParaRPr lang="en-US" sz="2000" dirty="0"/>
-          </a:p>
-        </p:txBody>
-      </p:sp>
-      <p:sp>
-        <p:nvSpPr>
-          <p:cNvPr id="6" name="Text 4"/>
-          <p:cNvSpPr txBox="1"/>
-          <p:nvPr/>
-        </p:nvSpPr>
-        <p:spPr>
-          <a:xfrm>
-            <a:off x="1508760" y="1837944"/>
-            <a:ext cx="9875520" cy="365760"/>
-          </a:xfrm>
-          <a:prstGeom prst="rect">
-            <a:avLst/>
-          </a:prstGeom>
-          <a:noFill/>
-          <a:ln/>
-        </p:spPr>
-        <p:txBody>
-          <a:bodyPr wrap="square" lIns="0" tIns="0" rIns="0" bIns="0" rtlCol="0" anchor="ctr"/>
-          <a:lstStyle/>
-          <a:p>
-            <a:pPr indent="0" marL="0">
-              <a:buNone/>
-            </a:pPr>
-            <a:r>
-              <a:rPr lang="en-US" sz="2000" b="1" dirty="0">
-                <a:solidFill>
-                  <a:schemeClr val="tx1"/>
-                </a:solidFill>
-              </a:rPr>
-              <a:t>Le dépôt GitHub de l'équipe</a:t>
-            </a:r>
-            <a:endParaRPr lang="en-US" sz="2000" dirty="0"/>
-          </a:p>
-        </p:txBody>
-      </p:sp>
-      <p:sp>
-        <p:nvSpPr>
-          <p:cNvPr id="7" name="Text 5"/>
-          <p:cNvSpPr txBox="1"/>
-          <p:nvPr/>
-        </p:nvSpPr>
-        <p:spPr>
-          <a:xfrm>
-            <a:off x="1508760" y="2185416"/>
-            <a:ext cx="9875520" cy="292608"/>
-          </a:xfrm>
-          <a:prstGeom prst="rect">
-            <a:avLst/>
-          </a:prstGeom>
-          <a:noFill/>
-          <a:ln/>
-        </p:spPr>
-        <p:txBody>
-          <a:bodyPr wrap="square" lIns="0" tIns="0" rIns="0" bIns="0" rtlCol="0" anchor="ctr"/>
-          <a:lstStyle/>
-          <a:p>
-            <a:pPr indent="0" marL="0">
-              <a:buNone/>
-            </a:pPr>
-            <a:r>
-              <a:rPr lang="en-US" sz="1400" dirty="0">
-                <a:solidFill>
-                  <a:schemeClr val="tx2"/>
-                </a:solidFill>
-              </a:rPr>
-              <a:t>Avec marie-michelle-ouellet comme collaboratrice</a:t>
-            </a:r>
-            <a:endParaRPr lang="en-US" sz="1400" dirty="0"/>
-          </a:p>
-        </p:txBody>
-      </p:sp>
-      <p:sp>
-        <p:nvSpPr>
-          <p:cNvPr id="8" name="etape-1"/>
-          <p:cNvSpPr/>
-          <p:nvPr/>
-        </p:nvSpPr>
-        <p:spPr>
-          <a:xfrm>
-            <a:off x="731520" y="2743200"/>
-            <a:ext cx="566928" cy="566928"/>
-          </a:xfrm>
-          <a:prstGeom prst="ellipse">
-            <a:avLst/>
-          </a:prstGeom>
-          <a:solidFill>
-            <a:schemeClr val="accent1"/>
-          </a:solidFill>
-          <a:ln w="12700">
-            <a:solidFill>
-              <a:schemeClr val="accent1"/>
-            </a:solidFill>
-            <a:prstDash val="solid"/>
-          </a:ln>
-        </p:spPr>
-      </p:sp>
-      <p:sp>
-        <p:nvSpPr>
-          <p:cNvPr id="9" name="Text 7"/>
-          <p:cNvSpPr txBox="1"/>
-          <p:nvPr/>
-        </p:nvSpPr>
-        <p:spPr>
-          <a:xfrm>
-            <a:off x="731520" y="2743200"/>
-            <a:ext cx="566928" cy="566928"/>
-          </a:xfrm>
-          <a:prstGeom prst="rect">
-            <a:avLst/>
-          </a:prstGeom>
-          <a:noFill/>
-          <a:ln/>
-        </p:spPr>
-        <p:txBody>
-          <a:bodyPr wrap="square" lIns="0" tIns="0" rIns="0" bIns="0" rtlCol="0" anchor="ctr"/>
-          <a:lstStyle/>
-          <a:p>
-            <a:pPr algn="ctr" indent="0" marL="0">
-              <a:buNone/>
-            </a:pPr>
-            <a:r>
-              <a:rPr lang="en-US" sz="2000" b="1" dirty="0">
-                <a:solidFill>
-                  <a:schemeClr val="bg1"/>
-                </a:solidFill>
-              </a:rPr>
-              <a:t>2</a:t>
-            </a:r>
-            <a:endParaRPr lang="en-US" sz="2000" dirty="0"/>
-          </a:p>
-        </p:txBody>
-      </p:sp>
-      <p:sp>
-        <p:nvSpPr>
-          <p:cNvPr id="10" name="Text 8"/>
-          <p:cNvSpPr txBox="1"/>
-          <p:nvPr/>
-        </p:nvSpPr>
-        <p:spPr>
-          <a:xfrm>
-            <a:off x="1508760" y="2706624"/>
-            <a:ext cx="9875520" cy="365760"/>
-          </a:xfrm>
-          <a:prstGeom prst="rect">
-            <a:avLst/>
-          </a:prstGeom>
-          <a:noFill/>
-          <a:ln/>
-        </p:spPr>
-        <p:txBody>
-          <a:bodyPr wrap="square" lIns="0" tIns="0" rIns="0" bIns="0" rtlCol="0" anchor="ctr"/>
-          <a:lstStyle/>
-          <a:p>
-            <a:pPr indent="0" marL="0">
-              <a:buNone/>
-            </a:pPr>
-            <a:r>
-              <a:rPr lang="en-US" sz="2000" b="1" dirty="0">
-                <a:solidFill>
-                  <a:schemeClr val="tx1"/>
-                </a:solidFill>
-              </a:rPr>
-              <a:t>CAHIER-DE-CHARGES.md complet</a:t>
-            </a:r>
-            <a:endParaRPr lang="en-US" sz="2000" dirty="0"/>
-          </a:p>
-        </p:txBody>
-      </p:sp>
-      <p:sp>
-        <p:nvSpPr>
-          <p:cNvPr id="11" name="Text 9"/>
-          <p:cNvSpPr txBox="1"/>
-          <p:nvPr/>
-        </p:nvSpPr>
-        <p:spPr>
-          <a:xfrm>
-            <a:off x="1508760" y="3054096"/>
-            <a:ext cx="9875520" cy="292608"/>
-          </a:xfrm>
-          <a:prstGeom prst="rect">
-            <a:avLst/>
-          </a:prstGeom>
-          <a:noFill/>
-          <a:ln/>
-        </p:spPr>
-        <p:txBody>
-          <a:bodyPr wrap="square" lIns="0" tIns="0" rIns="0" bIns="0" rtlCol="0" anchor="ctr"/>
-          <a:lstStyle/>
-          <a:p>
-            <a:pPr indent="0" marL="0">
-              <a:buNone/>
-            </a:pPr>
-            <a:r>
-              <a:rPr lang="en-US" sz="1400" dirty="0">
-                <a:solidFill>
-                  <a:schemeClr val="tx2"/>
-                </a:solidFill>
-              </a:rPr>
-              <a:t>À partir du gabarit</a:t>
-            </a:r>
-            <a:endParaRPr lang="en-US" sz="1400" dirty="0"/>
-          </a:p>
-        </p:txBody>
-      </p:sp>
-      <p:sp>
-        <p:nvSpPr>
-          <p:cNvPr id="12" name="etape-2"/>
-          <p:cNvSpPr/>
-          <p:nvPr/>
-        </p:nvSpPr>
-        <p:spPr>
-          <a:xfrm>
-            <a:off x="731520" y="3611880"/>
-            <a:ext cx="566928" cy="566928"/>
-          </a:xfrm>
-          <a:prstGeom prst="ellipse">
-            <a:avLst/>
-          </a:prstGeom>
-          <a:solidFill>
-            <a:schemeClr val="accent1"/>
-          </a:solidFill>
-          <a:ln w="12700">
-            <a:solidFill>
-              <a:schemeClr val="accent1"/>
-            </a:solidFill>
-            <a:prstDash val="solid"/>
-          </a:ln>
-        </p:spPr>
-      </p:sp>
-      <p:sp>
-        <p:nvSpPr>
-          <p:cNvPr id="13" name="Text 11"/>
-          <p:cNvSpPr txBox="1"/>
-          <p:nvPr/>
-        </p:nvSpPr>
-        <p:spPr>
-          <a:xfrm>
-            <a:off x="731520" y="3611880"/>
-            <a:ext cx="566928" cy="566928"/>
-          </a:xfrm>
-          <a:prstGeom prst="rect">
-            <a:avLst/>
-          </a:prstGeom>
-          <a:noFill/>
-          <a:ln/>
-        </p:spPr>
-        <p:txBody>
-          <a:bodyPr wrap="square" lIns="0" tIns="0" rIns="0" bIns="0" rtlCol="0" anchor="ctr"/>
-          <a:lstStyle/>
-          <a:p>
-            <a:pPr algn="ctr" indent="0" marL="0">
-              <a:buNone/>
-            </a:pPr>
-            <a:r>
-              <a:rPr lang="en-US" sz="2000" b="1" dirty="0">
-                <a:solidFill>
-                  <a:schemeClr val="bg1"/>
-                </a:solidFill>
-              </a:rPr>
-              <a:t>3</a:t>
-            </a:r>
-            <a:endParaRPr lang="en-US" sz="2000" dirty="0"/>
-          </a:p>
-        </p:txBody>
-      </p:sp>
-      <p:sp>
-        <p:nvSpPr>
-          <p:cNvPr id="14" name="Text 12"/>
-          <p:cNvSpPr txBox="1"/>
-          <p:nvPr/>
-        </p:nvSpPr>
-        <p:spPr>
-          <a:xfrm>
-            <a:off x="1508760" y="3575304"/>
-            <a:ext cx="9875520" cy="365760"/>
-          </a:xfrm>
-          <a:prstGeom prst="rect">
-            <a:avLst/>
-          </a:prstGeom>
-          <a:noFill/>
-          <a:ln/>
-        </p:spPr>
-        <p:txBody>
-          <a:bodyPr wrap="square" lIns="0" tIns="0" rIns="0" bIns="0" rtlCol="0" anchor="ctr"/>
-          <a:lstStyle/>
-          <a:p>
-            <a:pPr indent="0" marL="0">
-              <a:buNone/>
-            </a:pPr>
-            <a:r>
-              <a:rPr lang="en-US" sz="2000" b="1" dirty="0">
-                <a:solidFill>
-                  <a:schemeClr val="tx1"/>
-                </a:solidFill>
-              </a:rPr>
-              <a:t>Le storyboard dans Figma</a:t>
-            </a:r>
-            <a:endParaRPr lang="en-US" sz="2000" dirty="0"/>
-          </a:p>
-        </p:txBody>
-      </p:sp>
-      <p:sp>
-        <p:nvSpPr>
-          <p:cNvPr id="15" name="Text 13"/>
-          <p:cNvSpPr txBox="1"/>
-          <p:nvPr/>
-        </p:nvSpPr>
-        <p:spPr>
-          <a:xfrm>
-            <a:off x="1508760" y="3922776"/>
-            <a:ext cx="9875520" cy="292608"/>
-          </a:xfrm>
-          <a:prstGeom prst="rect">
-            <a:avLst/>
-          </a:prstGeom>
-          <a:noFill/>
-          <a:ln/>
-        </p:spPr>
-        <p:txBody>
-          <a:bodyPr wrap="square" lIns="0" tIns="0" rIns="0" bIns="0" rtlCol="0" anchor="ctr"/>
-          <a:lstStyle/>
-          <a:p>
-            <a:pPr indent="0" marL="0">
-              <a:buNone/>
-            </a:pPr>
-            <a:r>
-              <a:rPr lang="en-US" sz="1400" dirty="0">
-                <a:solidFill>
-                  <a:schemeClr val="tx2"/>
-                </a:solidFill>
-              </a:rPr>
-              <a:t>Lien dans le README, accès donné</a:t>
-            </a:r>
-            <a:endParaRPr lang="en-US" sz="1400" dirty="0"/>
-          </a:p>
-        </p:txBody>
-      </p:sp>
-      <p:sp>
-        <p:nvSpPr>
-          <p:cNvPr id="16" name="etape-3"/>
-          <p:cNvSpPr/>
-          <p:nvPr/>
-        </p:nvSpPr>
-        <p:spPr>
-          <a:xfrm>
-            <a:off x="731520" y="4480560"/>
-            <a:ext cx="566928" cy="566928"/>
-          </a:xfrm>
-          <a:prstGeom prst="ellipse">
-            <a:avLst/>
-          </a:prstGeom>
-          <a:solidFill>
-            <a:schemeClr val="accent1"/>
-          </a:solidFill>
-          <a:ln w="12700">
-            <a:solidFill>
-              <a:schemeClr val="accent1"/>
-            </a:solidFill>
-            <a:prstDash val="solid"/>
-          </a:ln>
-        </p:spPr>
-      </p:sp>
-      <p:sp>
-        <p:nvSpPr>
-          <p:cNvPr id="17" name="Text 15"/>
-          <p:cNvSpPr txBox="1"/>
-          <p:nvPr/>
-        </p:nvSpPr>
-        <p:spPr>
-          <a:xfrm>
-            <a:off x="731520" y="4480560"/>
-            <a:ext cx="566928" cy="566928"/>
-          </a:xfrm>
-          <a:prstGeom prst="rect">
-            <a:avLst/>
-          </a:prstGeom>
-          <a:noFill/>
-          <a:ln/>
-        </p:spPr>
-        <p:txBody>
-          <a:bodyPr wrap="square" lIns="0" tIns="0" rIns="0" bIns="0" rtlCol="0" anchor="ctr"/>
-          <a:lstStyle/>
-          <a:p>
-            <a:pPr algn="ctr" indent="0" marL="0">
-              <a:buNone/>
-            </a:pPr>
-            <a:r>
-              <a:rPr lang="en-US" sz="2000" b="1" dirty="0">
-                <a:solidFill>
-                  <a:schemeClr val="bg1"/>
-                </a:solidFill>
-              </a:rPr>
-              <a:t>4</a:t>
-            </a:r>
-            <a:endParaRPr lang="en-US" sz="2000" dirty="0"/>
-          </a:p>
-        </p:txBody>
-      </p:sp>
-      <p:sp>
-        <p:nvSpPr>
-          <p:cNvPr id="18" name="Text 16"/>
-          <p:cNvSpPr txBox="1"/>
-          <p:nvPr/>
-        </p:nvSpPr>
-        <p:spPr>
-          <a:xfrm>
-            <a:off x="1508760" y="4443984"/>
-            <a:ext cx="9875520" cy="365760"/>
-          </a:xfrm>
-          <a:prstGeom prst="rect">
-            <a:avLst/>
-          </a:prstGeom>
-          <a:noFill/>
-          <a:ln/>
-        </p:spPr>
-        <p:txBody>
-          <a:bodyPr wrap="square" lIns="0" tIns="0" rIns="0" bIns="0" rtlCol="0" anchor="ctr"/>
-          <a:lstStyle/>
-          <a:p>
-            <a:pPr indent="0" marL="0">
-              <a:buNone/>
-            </a:pPr>
-            <a:r>
-              <a:rPr lang="en-US" sz="2000" b="1" dirty="0">
-                <a:solidFill>
-                  <a:schemeClr val="tx1"/>
-                </a:solidFill>
-              </a:rPr>
-              <a:t>Un journal par personne</a:t>
-            </a:r>
-            <a:endParaRPr lang="en-US" sz="2000" dirty="0"/>
-          </a:p>
-        </p:txBody>
-      </p:sp>
-      <p:sp>
-        <p:nvSpPr>
-          <p:cNvPr id="19" name="Text 17"/>
-          <p:cNvSpPr txBox="1"/>
-          <p:nvPr/>
-        </p:nvSpPr>
-        <p:spPr>
-          <a:xfrm>
-            <a:off x="1508760" y="4791456"/>
-            <a:ext cx="9875520" cy="292608"/>
-          </a:xfrm>
-          <a:prstGeom prst="rect">
-            <a:avLst/>
-          </a:prstGeom>
-          <a:noFill/>
-          <a:ln/>
-        </p:spPr>
-        <p:txBody>
-          <a:bodyPr wrap="square" lIns="0" tIns="0" rIns="0" bIns="0" rtlCol="0" anchor="ctr"/>
-          <a:lstStyle/>
-          <a:p>
-            <a:pPr indent="0" marL="0">
-              <a:buNone/>
-            </a:pPr>
-            <a:r>
-              <a:rPr lang="en-US" sz="1400" dirty="0">
-                <a:solidFill>
-                  <a:schemeClr val="tx2"/>
-                </a:solidFill>
-              </a:rPr>
-              <a:t>Les 5 questions de ce premier bloc</a:t>
-            </a:r>
-            <a:endParaRPr lang="en-US" sz="1400" dirty="0"/>
           </a:p>
         </p:txBody>
       </p:sp>
@@ -8955,21 +8762,21 @@
             <a:r>
               <a:rPr lang="en-US" sz="3200" b="1" dirty="0">
                 <a:solidFill>
+                  <a:schemeClr val="tx1"/>
+                </a:solidFill>
+              </a:rPr>
+              <a:t>Remise 1 : </a:t>
+            </a:r>
+            <a:pPr algn="l" indent="0" marL="0">
+              <a:buNone/>
+            </a:pPr>
+            <a:r>
+              <a:rPr lang="en-US" sz="3200" b="1" dirty="0">
+                <a:solidFill>
                   <a:schemeClr val="accent1"/>
                 </a:solidFill>
               </a:rPr>
-              <a:t>Aujourd'hui</a:t>
-            </a:r>
-            <a:pPr algn="l" indent="0" marL="0">
-              <a:buNone/>
-            </a:pPr>
-            <a:r>
-              <a:rPr lang="en-US" sz="3200" b="1" dirty="0">
-                <a:solidFill>
-                  <a:schemeClr val="tx1"/>
-                </a:solidFill>
-              </a:rPr>
-              <a:t>.</a:t>
+              <a:t>ven. 23 oct.</a:t>
             </a:r>
             <a:endParaRPr lang="en-US" sz="3200" dirty="0"/>
           </a:p>
@@ -8977,13 +8784,49 @@
       </p:sp>
       <p:sp>
         <p:nvSpPr>
-          <p:cNvPr id="3" name="etape-0"/>
+          <p:cNvPr id="3" name="kicker"/>
+          <p:cNvSpPr txBox="1"/>
+          <p:nvPr/>
+        </p:nvSpPr>
+        <p:spPr>
+          <a:xfrm>
+            <a:off x="731520" y="1325880"/>
+            <a:ext cx="10698480" cy="365760"/>
+          </a:xfrm>
+          <a:prstGeom prst="rect">
+            <a:avLst/>
+          </a:prstGeom>
+          <a:noFill/>
+          <a:ln/>
+        </p:spPr>
+        <p:txBody>
+          <a:bodyPr wrap="square" lIns="0" tIns="0" rIns="0" bIns="0" rtlCol="0" anchor="ctr"/>
+          <a:lstStyle/>
+          <a:p>
+            <a:pPr indent="0" marL="0">
+              <a:buNone/>
+            </a:pPr>
+            <a:r>
+              <a:rPr lang="en-US" sz="1300" spc="400" kern="0" dirty="0">
+                <a:solidFill>
+                  <a:schemeClr val="tx2"/>
+                </a:solidFill>
+              </a:rPr>
+              <a:t>AU DÉBUT DU COURS</a:t>
+            </a:r>
+            <a:endParaRPr lang="en-US" sz="1300" dirty="0"/>
+          </a:p>
+        </p:txBody>
+      </p:sp>
+      <p:sp>
+        <p:nvSpPr>
+          <p:cNvPr id="4" name="etape-0"/>
           <p:cNvSpPr/>
           <p:nvPr/>
         </p:nvSpPr>
         <p:spPr>
           <a:xfrm>
-            <a:off x="731520" y="1737360"/>
+            <a:off x="731520" y="1874520"/>
             <a:ext cx="566928" cy="566928"/>
           </a:xfrm>
           <a:prstGeom prst="ellipse">
@@ -9002,13 +8845,13 @@
       </p:sp>
       <p:sp>
         <p:nvSpPr>
-          <p:cNvPr id="4" name="Text 2"/>
-          <p:cNvSpPr txBox="1"/>
-          <p:nvPr/>
-        </p:nvSpPr>
-        <p:spPr>
-          <a:xfrm>
-            <a:off x="731520" y="1737360"/>
+          <p:cNvPr id="5" name="Text 3"/>
+          <p:cNvSpPr txBox="1"/>
+          <p:nvPr/>
+        </p:nvSpPr>
+        <p:spPr>
+          <a:xfrm>
+            <a:off x="731520" y="1874520"/>
             <a:ext cx="566928" cy="566928"/>
           </a:xfrm>
           <a:prstGeom prst="rect">
@@ -9038,13 +8881,13 @@
       </p:sp>
       <p:sp>
         <p:nvSpPr>
-          <p:cNvPr id="5" name="Text 3"/>
-          <p:cNvSpPr txBox="1"/>
-          <p:nvPr/>
-        </p:nvSpPr>
-        <p:spPr>
-          <a:xfrm>
-            <a:off x="1508760" y="1700784"/>
+          <p:cNvPr id="6" name="Text 4"/>
+          <p:cNvSpPr txBox="1"/>
+          <p:nvPr/>
+        </p:nvSpPr>
+        <p:spPr>
+          <a:xfrm>
+            <a:off x="1508760" y="1837944"/>
             <a:ext cx="9875520" cy="365760"/>
           </a:xfrm>
           <a:prstGeom prst="rect">
@@ -9066,7 +8909,7 @@
                   <a:schemeClr val="tx1"/>
                 </a:solidFill>
               </a:rPr>
-              <a:t>Formez votre équipe</a:t>
+              <a:t>Le dépôt GitHub de l'équipe</a:t>
             </a:r>
             <a:endParaRPr lang="en-US" sz="2000" dirty="0"/>
           </a:p>
@@ -9074,13 +8917,13 @@
       </p:sp>
       <p:sp>
         <p:nvSpPr>
-          <p:cNvPr id="6" name="Text 4"/>
-          <p:cNvSpPr txBox="1"/>
-          <p:nvPr/>
-        </p:nvSpPr>
-        <p:spPr>
-          <a:xfrm>
-            <a:off x="1508760" y="2048256"/>
+          <p:cNvPr id="7" name="Text 5"/>
+          <p:cNvSpPr txBox="1"/>
+          <p:nvPr/>
+        </p:nvSpPr>
+        <p:spPr>
+          <a:xfrm>
+            <a:off x="1508760" y="2185416"/>
             <a:ext cx="9875520" cy="292608"/>
           </a:xfrm>
           <a:prstGeom prst="rect">
@@ -9102,7 +8945,7 @@
                   <a:schemeClr val="tx2"/>
                 </a:solidFill>
               </a:rPr>
-              <a:t>Échangez vos coordonnées pour travailler à distance</a:t>
+              <a:t>Avec marie-michelle-ouellet comme collaboratrice</a:t>
             </a:r>
             <a:endParaRPr lang="en-US" sz="1400" dirty="0"/>
           </a:p>
@@ -9110,13 +8953,13 @@
       </p:sp>
       <p:sp>
         <p:nvSpPr>
-          <p:cNvPr id="7" name="etape-1"/>
+          <p:cNvPr id="8" name="etape-1"/>
           <p:cNvSpPr/>
           <p:nvPr/>
         </p:nvSpPr>
         <p:spPr>
           <a:xfrm>
-            <a:off x="731520" y="2788920"/>
+            <a:off x="731520" y="2743200"/>
             <a:ext cx="566928" cy="566928"/>
           </a:xfrm>
           <a:prstGeom prst="ellipse">
@@ -9135,13 +8978,13 @@
       </p:sp>
       <p:sp>
         <p:nvSpPr>
-          <p:cNvPr id="8" name="Text 6"/>
-          <p:cNvSpPr txBox="1"/>
-          <p:nvPr/>
-        </p:nvSpPr>
-        <p:spPr>
-          <a:xfrm>
-            <a:off x="731520" y="2788920"/>
+          <p:cNvPr id="9" name="Text 7"/>
+          <p:cNvSpPr txBox="1"/>
+          <p:nvPr/>
+        </p:nvSpPr>
+        <p:spPr>
+          <a:xfrm>
+            <a:off x="731520" y="2743200"/>
             <a:ext cx="566928" cy="566928"/>
           </a:xfrm>
           <a:prstGeom prst="rect">
@@ -9171,13 +9014,13 @@
       </p:sp>
       <p:sp>
         <p:nvSpPr>
-          <p:cNvPr id="9" name="Text 7"/>
-          <p:cNvSpPr txBox="1"/>
-          <p:nvPr/>
-        </p:nvSpPr>
-        <p:spPr>
-          <a:xfrm>
-            <a:off x="1508760" y="2752344"/>
+          <p:cNvPr id="10" name="Text 8"/>
+          <p:cNvSpPr txBox="1"/>
+          <p:nvPr/>
+        </p:nvSpPr>
+        <p:spPr>
+          <a:xfrm>
+            <a:off x="1508760" y="2706624"/>
             <a:ext cx="9875520" cy="365760"/>
           </a:xfrm>
           <a:prstGeom prst="rect">
@@ -9199,7 +9042,7 @@
                   <a:schemeClr val="tx1"/>
                 </a:solidFill>
               </a:rPr>
-              <a:t>Choisissez un thème</a:t>
+              <a:t>CAHIER-DE-CHARGES.md complet</a:t>
             </a:r>
             <a:endParaRPr lang="en-US" sz="2000" dirty="0"/>
           </a:p>
@@ -9207,13 +9050,13 @@
       </p:sp>
       <p:sp>
         <p:nvSpPr>
-          <p:cNvPr id="10" name="Text 8"/>
-          <p:cNvSpPr txBox="1"/>
-          <p:nvPr/>
-        </p:nvSpPr>
-        <p:spPr>
-          <a:xfrm>
-            <a:off x="1508760" y="3099816"/>
+          <p:cNvPr id="11" name="Text 9"/>
+          <p:cNvSpPr txBox="1"/>
+          <p:nvPr/>
+        </p:nvSpPr>
+        <p:spPr>
+          <a:xfrm>
+            <a:off x="1508760" y="3054096"/>
             <a:ext cx="9875520" cy="292608"/>
           </a:xfrm>
           <a:prstGeom prst="rect">
@@ -9235,7 +9078,7 @@
                   <a:schemeClr val="tx2"/>
                 </a:solidFill>
               </a:rPr>
-              <a:t>3 idées chacun, puis une seule, en une phrase</a:t>
+              <a:t>À partir du gabarit</a:t>
             </a:r>
             <a:endParaRPr lang="en-US" sz="1400" dirty="0"/>
           </a:p>
@@ -9243,13 +9086,13 @@
       </p:sp>
       <p:sp>
         <p:nvSpPr>
-          <p:cNvPr id="11" name="etape-2"/>
+          <p:cNvPr id="12" name="etape-2"/>
           <p:cNvSpPr/>
           <p:nvPr/>
         </p:nvSpPr>
         <p:spPr>
           <a:xfrm>
-            <a:off x="731520" y="3840480"/>
+            <a:off x="731520" y="3611880"/>
             <a:ext cx="566928" cy="566928"/>
           </a:xfrm>
           <a:prstGeom prst="ellipse">
@@ -9268,13 +9111,13 @@
       </p:sp>
       <p:sp>
         <p:nvSpPr>
-          <p:cNvPr id="12" name="Text 10"/>
-          <p:cNvSpPr txBox="1"/>
-          <p:nvPr/>
-        </p:nvSpPr>
-        <p:spPr>
-          <a:xfrm>
-            <a:off x="731520" y="3840480"/>
+          <p:cNvPr id="13" name="Text 11"/>
+          <p:cNvSpPr txBox="1"/>
+          <p:nvPr/>
+        </p:nvSpPr>
+        <p:spPr>
+          <a:xfrm>
+            <a:off x="731520" y="3611880"/>
             <a:ext cx="566928" cy="566928"/>
           </a:xfrm>
           <a:prstGeom prst="rect">
@@ -9304,13 +9147,13 @@
       </p:sp>
       <p:sp>
         <p:nvSpPr>
-          <p:cNvPr id="13" name="Text 11"/>
-          <p:cNvSpPr txBox="1"/>
-          <p:nvPr/>
-        </p:nvSpPr>
-        <p:spPr>
-          <a:xfrm>
-            <a:off x="1508760" y="3803904"/>
+          <p:cNvPr id="14" name="Text 12"/>
+          <p:cNvSpPr txBox="1"/>
+          <p:nvPr/>
+        </p:nvSpPr>
+        <p:spPr>
+          <a:xfrm>
+            <a:off x="1508760" y="3575304"/>
             <a:ext cx="9875520" cy="365760"/>
           </a:xfrm>
           <a:prstGeom prst="rect">
@@ -9332,7 +9175,7 @@
                   <a:schemeClr val="tx1"/>
                 </a:solidFill>
               </a:rPr>
-              <a:t>Créez le dépôt et copiez le gabarit</a:t>
+              <a:t>Le storyboard dans Figma</a:t>
             </a:r>
             <a:endParaRPr lang="en-US" sz="2000" dirty="0"/>
           </a:p>
@@ -9340,13 +9183,13 @@
       </p:sp>
       <p:sp>
         <p:nvSpPr>
-          <p:cNvPr id="14" name="Text 12"/>
-          <p:cNvSpPr txBox="1"/>
-          <p:nvPr/>
-        </p:nvSpPr>
-        <p:spPr>
-          <a:xfrm>
-            <a:off x="1508760" y="4151376"/>
+          <p:cNvPr id="15" name="Text 13"/>
+          <p:cNvSpPr txBox="1"/>
+          <p:nvPr/>
+        </p:nvSpPr>
+        <p:spPr>
+          <a:xfrm>
+            <a:off x="1508760" y="3922776"/>
             <a:ext cx="9875520" cy="292608"/>
           </a:xfrm>
           <a:prstGeom prst="rect">
@@ -9368,7 +9211,7 @@
                   <a:schemeClr val="tx2"/>
                 </a:solidFill>
               </a:rPr>
-              <a:t>Commencez par la section 1 : le concept</a:t>
+              <a:t>Lien dans le README, accès donné</a:t>
             </a:r>
             <a:endParaRPr lang="en-US" sz="1400" dirty="0"/>
           </a:p>
@@ -9376,14 +9219,75 @@
       </p:sp>
       <p:sp>
         <p:nvSpPr>
-          <p:cNvPr id="15" name="Text 13"/>
-          <p:cNvSpPr txBox="1"/>
-          <p:nvPr/>
-        </p:nvSpPr>
-        <p:spPr>
-          <a:xfrm>
-            <a:off x="731520" y="5120640"/>
-            <a:ext cx="10698480" cy="457200"/>
+          <p:cNvPr id="16" name="etape-3"/>
+          <p:cNvSpPr/>
+          <p:nvPr/>
+        </p:nvSpPr>
+        <p:spPr>
+          <a:xfrm>
+            <a:off x="731520" y="4480560"/>
+            <a:ext cx="566928" cy="566928"/>
+          </a:xfrm>
+          <a:prstGeom prst="ellipse">
+            <a:avLst/>
+          </a:prstGeom>
+          <a:solidFill>
+            <a:schemeClr val="accent1"/>
+          </a:solidFill>
+          <a:ln w="12700">
+            <a:solidFill>
+              <a:schemeClr val="accent1"/>
+            </a:solidFill>
+            <a:prstDash val="solid"/>
+          </a:ln>
+        </p:spPr>
+      </p:sp>
+      <p:sp>
+        <p:nvSpPr>
+          <p:cNvPr id="17" name="Text 15"/>
+          <p:cNvSpPr txBox="1"/>
+          <p:nvPr/>
+        </p:nvSpPr>
+        <p:spPr>
+          <a:xfrm>
+            <a:off x="731520" y="4480560"/>
+            <a:ext cx="566928" cy="566928"/>
+          </a:xfrm>
+          <a:prstGeom prst="rect">
+            <a:avLst/>
+          </a:prstGeom>
+          <a:noFill/>
+          <a:ln/>
+        </p:spPr>
+        <p:txBody>
+          <a:bodyPr wrap="square" lIns="0" tIns="0" rIns="0" bIns="0" rtlCol="0" anchor="ctr"/>
+          <a:lstStyle/>
+          <a:p>
+            <a:pPr algn="ctr" indent="0" marL="0">
+              <a:buNone/>
+            </a:pPr>
+            <a:r>
+              <a:rPr lang="en-US" sz="2000" b="1" dirty="0">
+                <a:solidFill>
+                  <a:schemeClr val="bg1"/>
+                </a:solidFill>
+              </a:rPr>
+              <a:t>4</a:t>
+            </a:r>
+            <a:endParaRPr lang="en-US" sz="2000" dirty="0"/>
+          </a:p>
+        </p:txBody>
+      </p:sp>
+      <p:sp>
+        <p:nvSpPr>
+          <p:cNvPr id="18" name="Text 16"/>
+          <p:cNvSpPr txBox="1"/>
+          <p:nvPr/>
+        </p:nvSpPr>
+        <p:spPr>
+          <a:xfrm>
+            <a:off x="1508760" y="4443984"/>
+            <a:ext cx="9875520" cy="365760"/>
           </a:xfrm>
           <a:prstGeom prst="rect">
             <a:avLst/>
@@ -9401,12 +9305,48 @@
             <a:r>
               <a:rPr lang="en-US" sz="2000" b="1" dirty="0">
                 <a:solidFill>
-                  <a:schemeClr val="accent1"/>
-                </a:solidFill>
-              </a:rPr>
-              <a:t>Faites valider votre thème avant de partir.</a:t>
+                  <a:schemeClr val="tx1"/>
+                </a:solidFill>
+              </a:rPr>
+              <a:t>Un journal par personne</a:t>
             </a:r>
             <a:endParaRPr lang="en-US" sz="2000" dirty="0"/>
+          </a:p>
+        </p:txBody>
+      </p:sp>
+      <p:sp>
+        <p:nvSpPr>
+          <p:cNvPr id="19" name="Text 17"/>
+          <p:cNvSpPr txBox="1"/>
+          <p:nvPr/>
+        </p:nvSpPr>
+        <p:spPr>
+          <a:xfrm>
+            <a:off x="1508760" y="4791456"/>
+            <a:ext cx="9875520" cy="292608"/>
+          </a:xfrm>
+          <a:prstGeom prst="rect">
+            <a:avLst/>
+          </a:prstGeom>
+          <a:noFill/>
+          <a:ln/>
+        </p:spPr>
+        <p:txBody>
+          <a:bodyPr wrap="square" lIns="0" tIns="0" rIns="0" bIns="0" rtlCol="0" anchor="ctr"/>
+          <a:lstStyle/>
+          <a:p>
+            <a:pPr indent="0" marL="0">
+              <a:buNone/>
+            </a:pPr>
+            <a:r>
+              <a:rPr lang="en-US" sz="1400" dirty="0">
+                <a:solidFill>
+                  <a:schemeClr val="tx2"/>
+                </a:solidFill>
+              </a:rPr>
+              <a:t>Les 5 questions de ce premier bloc</a:t>
+            </a:r>
+            <a:endParaRPr lang="en-US" sz="1400" dirty="0"/>
           </a:p>
         </p:txBody>
       </p:sp>
@@ -9450,6 +9390,560 @@
             <a:fld id="{F7021451-1387-4CA6-816F-3879F97B5CBC}" type="slidenum">
               <a:rPr b="0" lang="en-US"/>
               <a:t>20</a:t>
+            </a:fld>
+            <a:endParaRPr lang="en-US"/>
+          </a:p>
+        </p:txBody>
+      </p:sp>
+    </p:spTree>
+  </p:cSld>
+  <p:clrMapOvr>
+    <a:masterClrMapping/>
+  </p:clrMapOvr>
+</p:sld>
+</file>
+
+<file path=ppt/slides/slide21.xml><?xml version="1.0" encoding="utf-8"?>
+<p:sld xmlns:a="http://schemas.openxmlformats.org/drawingml/2006/main" xmlns:r="http://schemas.openxmlformats.org/officeDocument/2006/relationships" xmlns:p="http://schemas.openxmlformats.org/presentationml/2006/main">
+  <p:cSld name="Slide 21">
+    <p:spTree>
+      <p:nvGrpSpPr>
+        <p:cNvPr id="1" name=""/>
+        <p:cNvGrpSpPr/>
+        <p:nvPr/>
+      </p:nvGrpSpPr>
+      <p:grpSpPr>
+        <a:xfrm>
+          <a:off x="0" y="0"/>
+          <a:ext cx="0" cy="0"/>
+          <a:chOff x="0" y="0"/>
+          <a:chExt cx="0" cy="0"/>
+        </a:xfrm>
+      </p:grpSpPr>
+      <p:sp>
+        <p:nvSpPr>
+          <p:cNvPr id="2" name="Text 0"/>
+          <p:cNvSpPr/>
+          <p:nvPr>
+            <p:ph idx="100" type="title" hasCustomPrompt="1"/>
+          </p:nvPr>
+        </p:nvSpPr>
+        <p:spPr>
+          <a:xfrm>
+            <a:off x="731520" y="411480"/>
+            <a:ext cx="10698480" cy="822960"/>
+          </a:xfrm>
+          <a:prstGeom prst="rect">
+            <a:avLst/>
+          </a:prstGeom>
+          <a:noFill/>
+          <a:ln/>
+        </p:spPr>
+        <p:txBody>
+          <a:bodyPr wrap="square" lIns="0" tIns="0" rIns="0" bIns="0" rtlCol="0" anchor="ctr"/>
+          <a:lstStyle/>
+          <a:p>
+            <a:pPr algn="l" indent="0" marL="0">
+              <a:buNone/>
+            </a:pPr>
+            <a:r>
+              <a:rPr lang="en-US" sz="3200" b="1" dirty="0">
+                <a:solidFill>
+                  <a:schemeClr val="accent1"/>
+                </a:solidFill>
+              </a:rPr>
+              <a:t>Aujourd'hui</a:t>
+            </a:r>
+            <a:pPr algn="l" indent="0" marL="0">
+              <a:buNone/>
+            </a:pPr>
+            <a:r>
+              <a:rPr lang="en-US" sz="3200" b="1" dirty="0">
+                <a:solidFill>
+                  <a:schemeClr val="tx1"/>
+                </a:solidFill>
+              </a:rPr>
+              <a:t>.</a:t>
+            </a:r>
+            <a:endParaRPr lang="en-US" sz="3200" dirty="0"/>
+          </a:p>
+        </p:txBody>
+      </p:sp>
+      <p:sp>
+        <p:nvSpPr>
+          <p:cNvPr id="3" name="etape-0"/>
+          <p:cNvSpPr/>
+          <p:nvPr/>
+        </p:nvSpPr>
+        <p:spPr>
+          <a:xfrm>
+            <a:off x="731520" y="1737360"/>
+            <a:ext cx="566928" cy="566928"/>
+          </a:xfrm>
+          <a:prstGeom prst="ellipse">
+            <a:avLst/>
+          </a:prstGeom>
+          <a:solidFill>
+            <a:schemeClr val="accent1"/>
+          </a:solidFill>
+          <a:ln w="12700">
+            <a:solidFill>
+              <a:schemeClr val="accent1"/>
+            </a:solidFill>
+            <a:prstDash val="solid"/>
+          </a:ln>
+        </p:spPr>
+      </p:sp>
+      <p:sp>
+        <p:nvSpPr>
+          <p:cNvPr id="4" name="Text 2"/>
+          <p:cNvSpPr txBox="1"/>
+          <p:nvPr/>
+        </p:nvSpPr>
+        <p:spPr>
+          <a:xfrm>
+            <a:off x="731520" y="1737360"/>
+            <a:ext cx="566928" cy="566928"/>
+          </a:xfrm>
+          <a:prstGeom prst="rect">
+            <a:avLst/>
+          </a:prstGeom>
+          <a:noFill/>
+          <a:ln/>
+        </p:spPr>
+        <p:txBody>
+          <a:bodyPr wrap="square" lIns="0" tIns="0" rIns="0" bIns="0" rtlCol="0" anchor="ctr"/>
+          <a:lstStyle/>
+          <a:p>
+            <a:pPr algn="ctr" indent="0" marL="0">
+              <a:buNone/>
+            </a:pPr>
+            <a:r>
+              <a:rPr lang="en-US" sz="2000" b="1" dirty="0">
+                <a:solidFill>
+                  <a:schemeClr val="bg1"/>
+                </a:solidFill>
+              </a:rPr>
+              <a:t>1</a:t>
+            </a:r>
+            <a:endParaRPr lang="en-US" sz="2000" dirty="0"/>
+          </a:p>
+        </p:txBody>
+      </p:sp>
+      <p:sp>
+        <p:nvSpPr>
+          <p:cNvPr id="5" name="Text 3"/>
+          <p:cNvSpPr txBox="1"/>
+          <p:nvPr/>
+        </p:nvSpPr>
+        <p:spPr>
+          <a:xfrm>
+            <a:off x="1508760" y="1700784"/>
+            <a:ext cx="9875520" cy="365760"/>
+          </a:xfrm>
+          <a:prstGeom prst="rect">
+            <a:avLst/>
+          </a:prstGeom>
+          <a:noFill/>
+          <a:ln/>
+        </p:spPr>
+        <p:txBody>
+          <a:bodyPr wrap="square" lIns="0" tIns="0" rIns="0" bIns="0" rtlCol="0" anchor="ctr"/>
+          <a:lstStyle/>
+          <a:p>
+            <a:pPr indent="0" marL="0">
+              <a:buNone/>
+            </a:pPr>
+            <a:r>
+              <a:rPr lang="en-US" sz="2000" b="1" dirty="0">
+                <a:solidFill>
+                  <a:schemeClr val="tx1"/>
+                </a:solidFill>
+              </a:rPr>
+              <a:t>Formez votre équipe</a:t>
+            </a:r>
+            <a:endParaRPr lang="en-US" sz="2000" dirty="0"/>
+          </a:p>
+        </p:txBody>
+      </p:sp>
+      <p:sp>
+        <p:nvSpPr>
+          <p:cNvPr id="6" name="Text 4"/>
+          <p:cNvSpPr txBox="1"/>
+          <p:nvPr/>
+        </p:nvSpPr>
+        <p:spPr>
+          <a:xfrm>
+            <a:off x="1508760" y="2048256"/>
+            <a:ext cx="9875520" cy="292608"/>
+          </a:xfrm>
+          <a:prstGeom prst="rect">
+            <a:avLst/>
+          </a:prstGeom>
+          <a:noFill/>
+          <a:ln/>
+        </p:spPr>
+        <p:txBody>
+          <a:bodyPr wrap="square" lIns="0" tIns="0" rIns="0" bIns="0" rtlCol="0" anchor="ctr"/>
+          <a:lstStyle/>
+          <a:p>
+            <a:pPr indent="0" marL="0">
+              <a:buNone/>
+            </a:pPr>
+            <a:r>
+              <a:rPr lang="en-US" sz="1400" dirty="0">
+                <a:solidFill>
+                  <a:schemeClr val="tx2"/>
+                </a:solidFill>
+              </a:rPr>
+              <a:t>Échangez vos coordonnées pour travailler à distance</a:t>
+            </a:r>
+            <a:endParaRPr lang="en-US" sz="1400" dirty="0"/>
+          </a:p>
+        </p:txBody>
+      </p:sp>
+      <p:sp>
+        <p:nvSpPr>
+          <p:cNvPr id="7" name="etape-1"/>
+          <p:cNvSpPr/>
+          <p:nvPr/>
+        </p:nvSpPr>
+        <p:spPr>
+          <a:xfrm>
+            <a:off x="731520" y="2788920"/>
+            <a:ext cx="566928" cy="566928"/>
+          </a:xfrm>
+          <a:prstGeom prst="ellipse">
+            <a:avLst/>
+          </a:prstGeom>
+          <a:solidFill>
+            <a:schemeClr val="accent1"/>
+          </a:solidFill>
+          <a:ln w="12700">
+            <a:solidFill>
+              <a:schemeClr val="accent1"/>
+            </a:solidFill>
+            <a:prstDash val="solid"/>
+          </a:ln>
+        </p:spPr>
+      </p:sp>
+      <p:sp>
+        <p:nvSpPr>
+          <p:cNvPr id="8" name="Text 6"/>
+          <p:cNvSpPr txBox="1"/>
+          <p:nvPr/>
+        </p:nvSpPr>
+        <p:spPr>
+          <a:xfrm>
+            <a:off x="731520" y="2788920"/>
+            <a:ext cx="566928" cy="566928"/>
+          </a:xfrm>
+          <a:prstGeom prst="rect">
+            <a:avLst/>
+          </a:prstGeom>
+          <a:noFill/>
+          <a:ln/>
+        </p:spPr>
+        <p:txBody>
+          <a:bodyPr wrap="square" lIns="0" tIns="0" rIns="0" bIns="0" rtlCol="0" anchor="ctr"/>
+          <a:lstStyle/>
+          <a:p>
+            <a:pPr algn="ctr" indent="0" marL="0">
+              <a:buNone/>
+            </a:pPr>
+            <a:r>
+              <a:rPr lang="en-US" sz="2000" b="1" dirty="0">
+                <a:solidFill>
+                  <a:schemeClr val="bg1"/>
+                </a:solidFill>
+              </a:rPr>
+              <a:t>2</a:t>
+            </a:r>
+            <a:endParaRPr lang="en-US" sz="2000" dirty="0"/>
+          </a:p>
+        </p:txBody>
+      </p:sp>
+      <p:sp>
+        <p:nvSpPr>
+          <p:cNvPr id="9" name="Text 7"/>
+          <p:cNvSpPr txBox="1"/>
+          <p:nvPr/>
+        </p:nvSpPr>
+        <p:spPr>
+          <a:xfrm>
+            <a:off x="1508760" y="2752344"/>
+            <a:ext cx="9875520" cy="365760"/>
+          </a:xfrm>
+          <a:prstGeom prst="rect">
+            <a:avLst/>
+          </a:prstGeom>
+          <a:noFill/>
+          <a:ln/>
+        </p:spPr>
+        <p:txBody>
+          <a:bodyPr wrap="square" lIns="0" tIns="0" rIns="0" bIns="0" rtlCol="0" anchor="ctr"/>
+          <a:lstStyle/>
+          <a:p>
+            <a:pPr indent="0" marL="0">
+              <a:buNone/>
+            </a:pPr>
+            <a:r>
+              <a:rPr lang="en-US" sz="2000" b="1" dirty="0">
+                <a:solidFill>
+                  <a:schemeClr val="tx1"/>
+                </a:solidFill>
+              </a:rPr>
+              <a:t>Choisissez un thème</a:t>
+            </a:r>
+            <a:endParaRPr lang="en-US" sz="2000" dirty="0"/>
+          </a:p>
+        </p:txBody>
+      </p:sp>
+      <p:sp>
+        <p:nvSpPr>
+          <p:cNvPr id="10" name="Text 8"/>
+          <p:cNvSpPr txBox="1"/>
+          <p:nvPr/>
+        </p:nvSpPr>
+        <p:spPr>
+          <a:xfrm>
+            <a:off x="1508760" y="3099816"/>
+            <a:ext cx="9875520" cy="292608"/>
+          </a:xfrm>
+          <a:prstGeom prst="rect">
+            <a:avLst/>
+          </a:prstGeom>
+          <a:noFill/>
+          <a:ln/>
+        </p:spPr>
+        <p:txBody>
+          <a:bodyPr wrap="square" lIns="0" tIns="0" rIns="0" bIns="0" rtlCol="0" anchor="ctr"/>
+          <a:lstStyle/>
+          <a:p>
+            <a:pPr indent="0" marL="0">
+              <a:buNone/>
+            </a:pPr>
+            <a:r>
+              <a:rPr lang="en-US" sz="1400" dirty="0">
+                <a:solidFill>
+                  <a:schemeClr val="tx2"/>
+                </a:solidFill>
+              </a:rPr>
+              <a:t>3 idées chacun, puis une seule, en une phrase</a:t>
+            </a:r>
+            <a:endParaRPr lang="en-US" sz="1400" dirty="0"/>
+          </a:p>
+        </p:txBody>
+      </p:sp>
+      <p:sp>
+        <p:nvSpPr>
+          <p:cNvPr id="11" name="etape-2"/>
+          <p:cNvSpPr/>
+          <p:nvPr/>
+        </p:nvSpPr>
+        <p:spPr>
+          <a:xfrm>
+            <a:off x="731520" y="3840480"/>
+            <a:ext cx="566928" cy="566928"/>
+          </a:xfrm>
+          <a:prstGeom prst="ellipse">
+            <a:avLst/>
+          </a:prstGeom>
+          <a:solidFill>
+            <a:schemeClr val="accent1"/>
+          </a:solidFill>
+          <a:ln w="12700">
+            <a:solidFill>
+              <a:schemeClr val="accent1"/>
+            </a:solidFill>
+            <a:prstDash val="solid"/>
+          </a:ln>
+        </p:spPr>
+      </p:sp>
+      <p:sp>
+        <p:nvSpPr>
+          <p:cNvPr id="12" name="Text 10"/>
+          <p:cNvSpPr txBox="1"/>
+          <p:nvPr/>
+        </p:nvSpPr>
+        <p:spPr>
+          <a:xfrm>
+            <a:off x="731520" y="3840480"/>
+            <a:ext cx="566928" cy="566928"/>
+          </a:xfrm>
+          <a:prstGeom prst="rect">
+            <a:avLst/>
+          </a:prstGeom>
+          <a:noFill/>
+          <a:ln/>
+        </p:spPr>
+        <p:txBody>
+          <a:bodyPr wrap="square" lIns="0" tIns="0" rIns="0" bIns="0" rtlCol="0" anchor="ctr"/>
+          <a:lstStyle/>
+          <a:p>
+            <a:pPr algn="ctr" indent="0" marL="0">
+              <a:buNone/>
+            </a:pPr>
+            <a:r>
+              <a:rPr lang="en-US" sz="2000" b="1" dirty="0">
+                <a:solidFill>
+                  <a:schemeClr val="bg1"/>
+                </a:solidFill>
+              </a:rPr>
+              <a:t>3</a:t>
+            </a:r>
+            <a:endParaRPr lang="en-US" sz="2000" dirty="0"/>
+          </a:p>
+        </p:txBody>
+      </p:sp>
+      <p:sp>
+        <p:nvSpPr>
+          <p:cNvPr id="13" name="Text 11"/>
+          <p:cNvSpPr txBox="1"/>
+          <p:nvPr/>
+        </p:nvSpPr>
+        <p:spPr>
+          <a:xfrm>
+            <a:off x="1508760" y="3803904"/>
+            <a:ext cx="9875520" cy="365760"/>
+          </a:xfrm>
+          <a:prstGeom prst="rect">
+            <a:avLst/>
+          </a:prstGeom>
+          <a:noFill/>
+          <a:ln/>
+        </p:spPr>
+        <p:txBody>
+          <a:bodyPr wrap="square" lIns="0" tIns="0" rIns="0" bIns="0" rtlCol="0" anchor="ctr"/>
+          <a:lstStyle/>
+          <a:p>
+            <a:pPr indent="0" marL="0">
+              <a:buNone/>
+            </a:pPr>
+            <a:r>
+              <a:rPr lang="en-US" sz="2000" b="1" dirty="0">
+                <a:solidFill>
+                  <a:schemeClr val="tx1"/>
+                </a:solidFill>
+              </a:rPr>
+              <a:t>Créez le dépôt et copiez le gabarit</a:t>
+            </a:r>
+            <a:endParaRPr lang="en-US" sz="2000" dirty="0"/>
+          </a:p>
+        </p:txBody>
+      </p:sp>
+      <p:sp>
+        <p:nvSpPr>
+          <p:cNvPr id="14" name="Text 12"/>
+          <p:cNvSpPr txBox="1"/>
+          <p:nvPr/>
+        </p:nvSpPr>
+        <p:spPr>
+          <a:xfrm>
+            <a:off x="1508760" y="4151376"/>
+            <a:ext cx="9875520" cy="292608"/>
+          </a:xfrm>
+          <a:prstGeom prst="rect">
+            <a:avLst/>
+          </a:prstGeom>
+          <a:noFill/>
+          <a:ln/>
+        </p:spPr>
+        <p:txBody>
+          <a:bodyPr wrap="square" lIns="0" tIns="0" rIns="0" bIns="0" rtlCol="0" anchor="ctr"/>
+          <a:lstStyle/>
+          <a:p>
+            <a:pPr indent="0" marL="0">
+              <a:buNone/>
+            </a:pPr>
+            <a:r>
+              <a:rPr lang="en-US" sz="1400" dirty="0">
+                <a:solidFill>
+                  <a:schemeClr val="tx2"/>
+                </a:solidFill>
+              </a:rPr>
+              <a:t>Commencez par la section 1 : le concept</a:t>
+            </a:r>
+            <a:endParaRPr lang="en-US" sz="1400" dirty="0"/>
+          </a:p>
+        </p:txBody>
+      </p:sp>
+      <p:sp>
+        <p:nvSpPr>
+          <p:cNvPr id="15" name="Text 13"/>
+          <p:cNvSpPr txBox="1"/>
+          <p:nvPr/>
+        </p:nvSpPr>
+        <p:spPr>
+          <a:xfrm>
+            <a:off x="731520" y="5120640"/>
+            <a:ext cx="10698480" cy="457200"/>
+          </a:xfrm>
+          <a:prstGeom prst="rect">
+            <a:avLst/>
+          </a:prstGeom>
+          <a:noFill/>
+          <a:ln/>
+        </p:spPr>
+        <p:txBody>
+          <a:bodyPr wrap="square" lIns="0" tIns="0" rIns="0" bIns="0" rtlCol="0" anchor="ctr"/>
+          <a:lstStyle/>
+          <a:p>
+            <a:pPr indent="0" marL="0">
+              <a:buNone/>
+            </a:pPr>
+            <a:r>
+              <a:rPr lang="en-US" sz="2000" b="1" dirty="0">
+                <a:solidFill>
+                  <a:schemeClr val="accent1"/>
+                </a:solidFill>
+              </a:rPr>
+              <a:t>Faites valider votre thème avant de partir.</a:t>
+            </a:r>
+            <a:endParaRPr lang="en-US" sz="2000" dirty="0"/>
+          </a:p>
+        </p:txBody>
+      </p:sp>
+      <p:sp>
+        <p:nvSpPr>
+          <p:cNvPr id="25" name="Slide Number Placeholder 0"/>
+          <p:cNvSpPr>
+            <a:spLocks noGrp="1"/>
+          </p:cNvSpPr>
+          <p:nvPr>
+            <p:ph type="sldNum" sz="quarter" idx="4294967295"/>
+          </p:nvPr>
+        </p:nvSpPr>
+        <p:spPr>
+          <a:xfrm>
+            <a:off x="11247120" y="6355080"/>
+            <a:ext cx="548640" cy="274320"/>
+          </a:xfrm>
+          <a:prstGeom prst="rect">
+            <a:avLst/>
+          </a:prstGeom>
+          <a:extLst>
+            <a:ext uri="{C572A759-6A51-4108-AA02-DFA0A04FC94B}">
+              <ma14:wrappingTextBoxFlag xmlns:ma14="http://schemas.microsoft.com/office/mac/drawingml/2011/main" val="0"/>
+            </a:ext>
+          </a:extLst>
+        </p:spPr>
+        <p:txBody>
+          <a:bodyPr/>
+          <a:lstStyle>
+            <a:lvl1pPr>
+              <a:defRPr sz="1000">
+                <a:solidFill>
+                  <a:schemeClr val="tx2"/>
+                </a:solidFill>
+              </a:defRPr>
+            </a:lvl1pPr>
+          </a:lstStyle>
+          <a:p>
+            <a:pPr algn="r"/>
+            <a:fld id="{F7021451-1387-4CA6-816F-3879F97B5CBC}" type="slidenum">
+              <a:rPr b="0" lang="en-US"/>
+              <a:t>21</a:t>
             </a:fld>
             <a:endParaRPr lang="en-US"/>
           </a:p>

</xml_diff>